<commit_message>
Add RESET button and auto-reset-on-return for question timers
- Each question slide now has a RESET button next to START that cancels
  any running countdown and restores the original editable duration
- Added PhysicsLeagueTimerEvents.cls + a ThisPresentation snippet that
  detect slide changes during the slideshow: if a timer already reached
  TIME UP, it auto-resets the moment the host returns to that slide; a
  timer left mid-countdown stays frozen until RESET or START is clicked
- Updated the in-deck Host Setup slide with the extra import/paste steps
</commit_message>
<xml_diff>
--- a/Physics-League-Kinematics-Championship.pptx
+++ b/Physics-League-Kinematics-Championship.pptx
@@ -5812,7 +5812,7 @@
         </p:nvSpPr>
         <p:spPr>
           <a:xfrm>
-            <a:off x="4178808" y="896112"/>
+            <a:off x="3790188" y="896112"/>
             <a:ext cx="310896" cy="384048"/>
           </a:xfrm>
           <a:prstGeom prst="rect">
@@ -5851,7 +5851,7 @@
         </p:nvSpPr>
         <p:spPr>
           <a:xfrm>
-            <a:off x="4581144" y="896112"/>
+            <a:off x="4192524" y="896112"/>
             <a:ext cx="868680" cy="384048"/>
           </a:xfrm>
           <a:prstGeom prst="roundRect">
@@ -5878,7 +5878,7 @@
         </p:nvSpPr>
         <p:spPr>
           <a:xfrm>
-            <a:off x="4581144" y="896112"/>
+            <a:off x="4192524" y="896112"/>
             <a:ext cx="868680" cy="384048"/>
           </a:xfrm>
           <a:prstGeom prst="rect">
@@ -5917,7 +5917,7 @@
         </p:nvSpPr>
         <p:spPr>
           <a:xfrm>
-            <a:off x="5541264" y="896112"/>
+            <a:off x="5152644" y="896112"/>
             <a:ext cx="1143000" cy="384048"/>
           </a:xfrm>
           <a:prstGeom prst="roundRect">
@@ -5944,7 +5944,7 @@
         </p:nvSpPr>
         <p:spPr>
           <a:xfrm>
-            <a:off x="5541264" y="896112"/>
+            <a:off x="5152644" y="896112"/>
             <a:ext cx="1143000" cy="384048"/>
           </a:xfrm>
           <a:prstGeom prst="rect">
@@ -5983,7 +5983,7 @@
         </p:nvSpPr>
         <p:spPr>
           <a:xfrm>
-            <a:off x="6775704" y="896112"/>
+            <a:off x="6387084" y="896112"/>
             <a:ext cx="1234440" cy="384048"/>
           </a:xfrm>
           <a:prstGeom prst="roundRect">
@@ -6010,7 +6010,7 @@
         </p:nvSpPr>
         <p:spPr>
           <a:xfrm>
-            <a:off x="6775704" y="896112"/>
+            <a:off x="6387084" y="896112"/>
             <a:ext cx="1234440" cy="384048"/>
           </a:xfrm>
           <a:prstGeom prst="rect">
@@ -6044,6 +6044,72 @@
       <p:sp>
         <p:nvSpPr>
           <p:cNvPr id="14" name="Shape 12"/>
+          <p:cNvSpPr/>
+          <p:nvPr/>
+        </p:nvSpPr>
+        <p:spPr>
+          <a:xfrm>
+            <a:off x="7712964" y="896112"/>
+            <a:ext cx="685800" cy="384048"/>
+          </a:xfrm>
+          <a:prstGeom prst="roundRect">
+            <a:avLst>
+              <a:gd name="adj" fmla="val 19048"/>
+            </a:avLst>
+          </a:prstGeom>
+          <a:solidFill>
+            <a:srgbClr val="262633"/>
+          </a:solidFill>
+          <a:ln w="12700">
+            <a:solidFill>
+              <a:srgbClr val="9A9AB0"/>
+            </a:solidFill>
+            <a:prstDash val="solid"/>
+          </a:ln>
+        </p:spPr>
+      </p:sp>
+      <p:sp>
+        <p:nvSpPr>
+          <p:cNvPr id="15" name="TimerResetBtn"/>
+          <p:cNvSpPr/>
+          <p:nvPr/>
+        </p:nvSpPr>
+        <p:spPr>
+          <a:xfrm>
+            <a:off x="7712964" y="896112"/>
+            <a:ext cx="685800" cy="384048"/>
+          </a:xfrm>
+          <a:prstGeom prst="rect">
+            <a:avLst/>
+          </a:prstGeom>
+          <a:noFill/>
+          <a:ln/>
+        </p:spPr>
+        <p:txBody>
+          <a:bodyPr wrap="square" lIns="0" tIns="0" rIns="0" bIns="0" rtlCol="0" anchor="ctr"/>
+          <a:lstStyle/>
+          <a:p>
+            <a:pPr algn="ctr" indent="0" marL="0">
+              <a:buNone/>
+            </a:pPr>
+            <a:r>
+              <a:rPr lang="en-US" sz="1100" b="1" dirty="0">
+                <a:solidFill>
+                  <a:srgbClr val="9A9AB0"/>
+                </a:solidFill>
+                <a:latin typeface="Calibri" pitchFamily="34" charset="0"/>
+                <a:ea typeface="Calibri" pitchFamily="34" charset="-122"/>
+                <a:cs typeface="Calibri" pitchFamily="34" charset="-120"/>
+              </a:rPr>
+              <a:t>RESET</a:t>
+            </a:r>
+            <a:endParaRPr lang="en-US" sz="1100" dirty="0"/>
+          </a:p>
+        </p:txBody>
+      </p:sp>
+      <p:sp>
+        <p:nvSpPr>
+          <p:cNvPr id="16" name="Shape 14"/>
           <p:cNvSpPr/>
           <p:nvPr/>
         </p:nvSpPr>
@@ -6070,7 +6136,7 @@
       </p:sp>
       <p:sp>
         <p:nvSpPr>
-          <p:cNvPr id="15" name="Text 13"/>
+          <p:cNvPr id="17" name="Text 15"/>
           <p:cNvSpPr/>
           <p:nvPr/>
         </p:nvSpPr>
@@ -6114,7 +6180,7 @@
       </p:sp>
       <p:sp>
         <p:nvSpPr>
-          <p:cNvPr id="16" name="Text 14"/>
+          <p:cNvPr id="18" name="Text 16"/>
           <p:cNvSpPr/>
           <p:nvPr/>
         </p:nvSpPr>
@@ -6153,7 +6219,7 @@
       </p:sp>
       <p:sp>
         <p:nvSpPr>
-          <p:cNvPr id="17" name="Text 15"/>
+          <p:cNvPr id="19" name="Text 17"/>
           <p:cNvSpPr/>
           <p:nvPr/>
         </p:nvSpPr>
@@ -6765,7 +6831,7 @@
         </p:nvSpPr>
         <p:spPr>
           <a:xfrm>
-            <a:off x="4178808" y="896112"/>
+            <a:off x="3790188" y="896112"/>
             <a:ext cx="310896" cy="384048"/>
           </a:xfrm>
           <a:prstGeom prst="rect">
@@ -6804,7 +6870,7 @@
         </p:nvSpPr>
         <p:spPr>
           <a:xfrm>
-            <a:off x="4581144" y="896112"/>
+            <a:off x="4192524" y="896112"/>
             <a:ext cx="868680" cy="384048"/>
           </a:xfrm>
           <a:prstGeom prst="roundRect">
@@ -6831,7 +6897,7 @@
         </p:nvSpPr>
         <p:spPr>
           <a:xfrm>
-            <a:off x="4581144" y="896112"/>
+            <a:off x="4192524" y="896112"/>
             <a:ext cx="868680" cy="384048"/>
           </a:xfrm>
           <a:prstGeom prst="rect">
@@ -6870,7 +6936,7 @@
         </p:nvSpPr>
         <p:spPr>
           <a:xfrm>
-            <a:off x="5541264" y="896112"/>
+            <a:off x="5152644" y="896112"/>
             <a:ext cx="1143000" cy="384048"/>
           </a:xfrm>
           <a:prstGeom prst="roundRect">
@@ -6897,7 +6963,7 @@
         </p:nvSpPr>
         <p:spPr>
           <a:xfrm>
-            <a:off x="5541264" y="896112"/>
+            <a:off x="5152644" y="896112"/>
             <a:ext cx="1143000" cy="384048"/>
           </a:xfrm>
           <a:prstGeom prst="rect">
@@ -6936,7 +7002,7 @@
         </p:nvSpPr>
         <p:spPr>
           <a:xfrm>
-            <a:off x="6775704" y="896112"/>
+            <a:off x="6387084" y="896112"/>
             <a:ext cx="1234440" cy="384048"/>
           </a:xfrm>
           <a:prstGeom prst="roundRect">
@@ -6963,7 +7029,7 @@
         </p:nvSpPr>
         <p:spPr>
           <a:xfrm>
-            <a:off x="6775704" y="896112"/>
+            <a:off x="6387084" y="896112"/>
             <a:ext cx="1234440" cy="384048"/>
           </a:xfrm>
           <a:prstGeom prst="rect">
@@ -6997,6 +7063,72 @@
       <p:sp>
         <p:nvSpPr>
           <p:cNvPr id="14" name="Shape 12"/>
+          <p:cNvSpPr/>
+          <p:nvPr/>
+        </p:nvSpPr>
+        <p:spPr>
+          <a:xfrm>
+            <a:off x="7712964" y="896112"/>
+            <a:ext cx="685800" cy="384048"/>
+          </a:xfrm>
+          <a:prstGeom prst="roundRect">
+            <a:avLst>
+              <a:gd name="adj" fmla="val 19048"/>
+            </a:avLst>
+          </a:prstGeom>
+          <a:solidFill>
+            <a:srgbClr val="262633"/>
+          </a:solidFill>
+          <a:ln w="12700">
+            <a:solidFill>
+              <a:srgbClr val="9A9AB0"/>
+            </a:solidFill>
+            <a:prstDash val="solid"/>
+          </a:ln>
+        </p:spPr>
+      </p:sp>
+      <p:sp>
+        <p:nvSpPr>
+          <p:cNvPr id="15" name="TimerResetBtn"/>
+          <p:cNvSpPr/>
+          <p:nvPr/>
+        </p:nvSpPr>
+        <p:spPr>
+          <a:xfrm>
+            <a:off x="7712964" y="896112"/>
+            <a:ext cx="685800" cy="384048"/>
+          </a:xfrm>
+          <a:prstGeom prst="rect">
+            <a:avLst/>
+          </a:prstGeom>
+          <a:noFill/>
+          <a:ln/>
+        </p:spPr>
+        <p:txBody>
+          <a:bodyPr wrap="square" lIns="0" tIns="0" rIns="0" bIns="0" rtlCol="0" anchor="ctr"/>
+          <a:lstStyle/>
+          <a:p>
+            <a:pPr algn="ctr" indent="0" marL="0">
+              <a:buNone/>
+            </a:pPr>
+            <a:r>
+              <a:rPr lang="en-US" sz="1100" b="1" dirty="0">
+                <a:solidFill>
+                  <a:srgbClr val="9A9AB0"/>
+                </a:solidFill>
+                <a:latin typeface="Calibri" pitchFamily="34" charset="0"/>
+                <a:ea typeface="Calibri" pitchFamily="34" charset="-122"/>
+                <a:cs typeface="Calibri" pitchFamily="34" charset="-120"/>
+              </a:rPr>
+              <a:t>RESET</a:t>
+            </a:r>
+            <a:endParaRPr lang="en-US" sz="1100" dirty="0"/>
+          </a:p>
+        </p:txBody>
+      </p:sp>
+      <p:sp>
+        <p:nvSpPr>
+          <p:cNvPr id="16" name="Shape 14"/>
           <p:cNvSpPr/>
           <p:nvPr/>
         </p:nvSpPr>
@@ -7023,7 +7155,7 @@
       </p:sp>
       <p:sp>
         <p:nvSpPr>
-          <p:cNvPr id="15" name="Text 13"/>
+          <p:cNvPr id="17" name="Text 15"/>
           <p:cNvSpPr/>
           <p:nvPr/>
         </p:nvSpPr>
@@ -7067,7 +7199,7 @@
       </p:sp>
       <p:sp>
         <p:nvSpPr>
-          <p:cNvPr id="16" name="Text 14"/>
+          <p:cNvPr id="18" name="Text 16"/>
           <p:cNvSpPr/>
           <p:nvPr/>
         </p:nvSpPr>
@@ -7106,7 +7238,7 @@
       </p:sp>
       <p:sp>
         <p:nvSpPr>
-          <p:cNvPr id="17" name="Text 15"/>
+          <p:cNvPr id="19" name="Text 17"/>
           <p:cNvSpPr/>
           <p:nvPr/>
         </p:nvSpPr>
@@ -7784,7 +7916,7 @@
         </p:nvSpPr>
         <p:spPr>
           <a:xfrm>
-            <a:off x="4178808" y="896112"/>
+            <a:off x="3790188" y="896112"/>
             <a:ext cx="310896" cy="384048"/>
           </a:xfrm>
           <a:prstGeom prst="rect">
@@ -7823,7 +7955,7 @@
         </p:nvSpPr>
         <p:spPr>
           <a:xfrm>
-            <a:off x="4581144" y="896112"/>
+            <a:off x="4192524" y="896112"/>
             <a:ext cx="868680" cy="384048"/>
           </a:xfrm>
           <a:prstGeom prst="roundRect">
@@ -7850,7 +7982,7 @@
         </p:nvSpPr>
         <p:spPr>
           <a:xfrm>
-            <a:off x="4581144" y="896112"/>
+            <a:off x="4192524" y="896112"/>
             <a:ext cx="868680" cy="384048"/>
           </a:xfrm>
           <a:prstGeom prst="rect">
@@ -7889,7 +8021,7 @@
         </p:nvSpPr>
         <p:spPr>
           <a:xfrm>
-            <a:off x="5541264" y="896112"/>
+            <a:off x="5152644" y="896112"/>
             <a:ext cx="1143000" cy="384048"/>
           </a:xfrm>
           <a:prstGeom prst="roundRect">
@@ -7916,7 +8048,7 @@
         </p:nvSpPr>
         <p:spPr>
           <a:xfrm>
-            <a:off x="5541264" y="896112"/>
+            <a:off x="5152644" y="896112"/>
             <a:ext cx="1143000" cy="384048"/>
           </a:xfrm>
           <a:prstGeom prst="rect">
@@ -7955,7 +8087,7 @@
         </p:nvSpPr>
         <p:spPr>
           <a:xfrm>
-            <a:off x="6775704" y="896112"/>
+            <a:off x="6387084" y="896112"/>
             <a:ext cx="1234440" cy="384048"/>
           </a:xfrm>
           <a:prstGeom prst="roundRect">
@@ -7982,7 +8114,7 @@
         </p:nvSpPr>
         <p:spPr>
           <a:xfrm>
-            <a:off x="6775704" y="896112"/>
+            <a:off x="6387084" y="896112"/>
             <a:ext cx="1234440" cy="384048"/>
           </a:xfrm>
           <a:prstGeom prst="rect">
@@ -8016,6 +8148,72 @@
       <p:sp>
         <p:nvSpPr>
           <p:cNvPr id="14" name="Shape 12"/>
+          <p:cNvSpPr/>
+          <p:nvPr/>
+        </p:nvSpPr>
+        <p:spPr>
+          <a:xfrm>
+            <a:off x="7712964" y="896112"/>
+            <a:ext cx="685800" cy="384048"/>
+          </a:xfrm>
+          <a:prstGeom prst="roundRect">
+            <a:avLst>
+              <a:gd name="adj" fmla="val 19048"/>
+            </a:avLst>
+          </a:prstGeom>
+          <a:solidFill>
+            <a:srgbClr val="262633"/>
+          </a:solidFill>
+          <a:ln w="12700">
+            <a:solidFill>
+              <a:srgbClr val="9A9AB0"/>
+            </a:solidFill>
+            <a:prstDash val="solid"/>
+          </a:ln>
+        </p:spPr>
+      </p:sp>
+      <p:sp>
+        <p:nvSpPr>
+          <p:cNvPr id="15" name="TimerResetBtn"/>
+          <p:cNvSpPr/>
+          <p:nvPr/>
+        </p:nvSpPr>
+        <p:spPr>
+          <a:xfrm>
+            <a:off x="7712964" y="896112"/>
+            <a:ext cx="685800" cy="384048"/>
+          </a:xfrm>
+          <a:prstGeom prst="rect">
+            <a:avLst/>
+          </a:prstGeom>
+          <a:noFill/>
+          <a:ln/>
+        </p:spPr>
+        <p:txBody>
+          <a:bodyPr wrap="square" lIns="0" tIns="0" rIns="0" bIns="0" rtlCol="0" anchor="ctr"/>
+          <a:lstStyle/>
+          <a:p>
+            <a:pPr algn="ctr" indent="0" marL="0">
+              <a:buNone/>
+            </a:pPr>
+            <a:r>
+              <a:rPr lang="en-US" sz="1100" b="1" dirty="0">
+                <a:solidFill>
+                  <a:srgbClr val="9A9AB0"/>
+                </a:solidFill>
+                <a:latin typeface="Calibri" pitchFamily="34" charset="0"/>
+                <a:ea typeface="Calibri" pitchFamily="34" charset="-122"/>
+                <a:cs typeface="Calibri" pitchFamily="34" charset="-120"/>
+              </a:rPr>
+              <a:t>RESET</a:t>
+            </a:r>
+            <a:endParaRPr lang="en-US" sz="1100" dirty="0"/>
+          </a:p>
+        </p:txBody>
+      </p:sp>
+      <p:sp>
+        <p:nvSpPr>
+          <p:cNvPr id="16" name="Shape 14"/>
           <p:cNvSpPr/>
           <p:nvPr/>
         </p:nvSpPr>
@@ -8042,7 +8240,7 @@
       </p:sp>
       <p:sp>
         <p:nvSpPr>
-          <p:cNvPr id="15" name="Text 13"/>
+          <p:cNvPr id="17" name="Text 15"/>
           <p:cNvSpPr/>
           <p:nvPr/>
         </p:nvSpPr>
@@ -8086,7 +8284,7 @@
       </p:sp>
       <p:sp>
         <p:nvSpPr>
-          <p:cNvPr id="16" name="Text 14"/>
+          <p:cNvPr id="18" name="Text 16"/>
           <p:cNvSpPr/>
           <p:nvPr/>
         </p:nvSpPr>
@@ -8125,7 +8323,7 @@
       </p:sp>
       <p:sp>
         <p:nvSpPr>
-          <p:cNvPr id="17" name="Text 15"/>
+          <p:cNvPr id="19" name="Text 17"/>
           <p:cNvSpPr/>
           <p:nvPr/>
         </p:nvSpPr>
@@ -8737,7 +8935,7 @@
         </p:nvSpPr>
         <p:spPr>
           <a:xfrm>
-            <a:off x="4178808" y="896112"/>
+            <a:off x="3790188" y="896112"/>
             <a:ext cx="310896" cy="384048"/>
           </a:xfrm>
           <a:prstGeom prst="rect">
@@ -8776,7 +8974,7 @@
         </p:nvSpPr>
         <p:spPr>
           <a:xfrm>
-            <a:off x="4581144" y="896112"/>
+            <a:off x="4192524" y="896112"/>
             <a:ext cx="868680" cy="384048"/>
           </a:xfrm>
           <a:prstGeom prst="roundRect">
@@ -8803,7 +9001,7 @@
         </p:nvSpPr>
         <p:spPr>
           <a:xfrm>
-            <a:off x="4581144" y="896112"/>
+            <a:off x="4192524" y="896112"/>
             <a:ext cx="868680" cy="384048"/>
           </a:xfrm>
           <a:prstGeom prst="rect">
@@ -8842,7 +9040,7 @@
         </p:nvSpPr>
         <p:spPr>
           <a:xfrm>
-            <a:off x="5541264" y="896112"/>
+            <a:off x="5152644" y="896112"/>
             <a:ext cx="1143000" cy="384048"/>
           </a:xfrm>
           <a:prstGeom prst="roundRect">
@@ -8869,7 +9067,7 @@
         </p:nvSpPr>
         <p:spPr>
           <a:xfrm>
-            <a:off x="5541264" y="896112"/>
+            <a:off x="5152644" y="896112"/>
             <a:ext cx="1143000" cy="384048"/>
           </a:xfrm>
           <a:prstGeom prst="rect">
@@ -8908,7 +9106,7 @@
         </p:nvSpPr>
         <p:spPr>
           <a:xfrm>
-            <a:off x="6775704" y="896112"/>
+            <a:off x="6387084" y="896112"/>
             <a:ext cx="1234440" cy="384048"/>
           </a:xfrm>
           <a:prstGeom prst="roundRect">
@@ -8935,7 +9133,7 @@
         </p:nvSpPr>
         <p:spPr>
           <a:xfrm>
-            <a:off x="6775704" y="896112"/>
+            <a:off x="6387084" y="896112"/>
             <a:ext cx="1234440" cy="384048"/>
           </a:xfrm>
           <a:prstGeom prst="rect">
@@ -8969,6 +9167,72 @@
       <p:sp>
         <p:nvSpPr>
           <p:cNvPr id="14" name="Shape 12"/>
+          <p:cNvSpPr/>
+          <p:nvPr/>
+        </p:nvSpPr>
+        <p:spPr>
+          <a:xfrm>
+            <a:off x="7712964" y="896112"/>
+            <a:ext cx="685800" cy="384048"/>
+          </a:xfrm>
+          <a:prstGeom prst="roundRect">
+            <a:avLst>
+              <a:gd name="adj" fmla="val 19048"/>
+            </a:avLst>
+          </a:prstGeom>
+          <a:solidFill>
+            <a:srgbClr val="262633"/>
+          </a:solidFill>
+          <a:ln w="12700">
+            <a:solidFill>
+              <a:srgbClr val="9A9AB0"/>
+            </a:solidFill>
+            <a:prstDash val="solid"/>
+          </a:ln>
+        </p:spPr>
+      </p:sp>
+      <p:sp>
+        <p:nvSpPr>
+          <p:cNvPr id="15" name="TimerResetBtn"/>
+          <p:cNvSpPr/>
+          <p:nvPr/>
+        </p:nvSpPr>
+        <p:spPr>
+          <a:xfrm>
+            <a:off x="7712964" y="896112"/>
+            <a:ext cx="685800" cy="384048"/>
+          </a:xfrm>
+          <a:prstGeom prst="rect">
+            <a:avLst/>
+          </a:prstGeom>
+          <a:noFill/>
+          <a:ln/>
+        </p:spPr>
+        <p:txBody>
+          <a:bodyPr wrap="square" lIns="0" tIns="0" rIns="0" bIns="0" rtlCol="0" anchor="ctr"/>
+          <a:lstStyle/>
+          <a:p>
+            <a:pPr algn="ctr" indent="0" marL="0">
+              <a:buNone/>
+            </a:pPr>
+            <a:r>
+              <a:rPr lang="en-US" sz="1100" b="1" dirty="0">
+                <a:solidFill>
+                  <a:srgbClr val="9A9AB0"/>
+                </a:solidFill>
+                <a:latin typeface="Calibri" pitchFamily="34" charset="0"/>
+                <a:ea typeface="Calibri" pitchFamily="34" charset="-122"/>
+                <a:cs typeface="Calibri" pitchFamily="34" charset="-120"/>
+              </a:rPr>
+              <a:t>RESET</a:t>
+            </a:r>
+            <a:endParaRPr lang="en-US" sz="1100" dirty="0"/>
+          </a:p>
+        </p:txBody>
+      </p:sp>
+      <p:sp>
+        <p:nvSpPr>
+          <p:cNvPr id="16" name="Shape 14"/>
           <p:cNvSpPr/>
           <p:nvPr/>
         </p:nvSpPr>
@@ -8995,7 +9259,7 @@
       </p:sp>
       <p:sp>
         <p:nvSpPr>
-          <p:cNvPr id="15" name="Text 13"/>
+          <p:cNvPr id="17" name="Text 15"/>
           <p:cNvSpPr/>
           <p:nvPr/>
         </p:nvSpPr>
@@ -9039,7 +9303,7 @@
       </p:sp>
       <p:sp>
         <p:nvSpPr>
-          <p:cNvPr id="16" name="Text 14"/>
+          <p:cNvPr id="18" name="Text 16"/>
           <p:cNvSpPr/>
           <p:nvPr/>
         </p:nvSpPr>
@@ -9078,7 +9342,7 @@
       </p:sp>
       <p:sp>
         <p:nvSpPr>
-          <p:cNvPr id="17" name="Text 15"/>
+          <p:cNvPr id="19" name="Text 17"/>
           <p:cNvSpPr/>
           <p:nvPr/>
         </p:nvSpPr>
@@ -9690,7 +9954,7 @@
         </p:nvSpPr>
         <p:spPr>
           <a:xfrm>
-            <a:off x="4178808" y="896112"/>
+            <a:off x="3790188" y="896112"/>
             <a:ext cx="310896" cy="384048"/>
           </a:xfrm>
           <a:prstGeom prst="rect">
@@ -9729,7 +9993,7 @@
         </p:nvSpPr>
         <p:spPr>
           <a:xfrm>
-            <a:off x="4581144" y="896112"/>
+            <a:off x="4192524" y="896112"/>
             <a:ext cx="868680" cy="384048"/>
           </a:xfrm>
           <a:prstGeom prst="roundRect">
@@ -9756,7 +10020,7 @@
         </p:nvSpPr>
         <p:spPr>
           <a:xfrm>
-            <a:off x="4581144" y="896112"/>
+            <a:off x="4192524" y="896112"/>
             <a:ext cx="868680" cy="384048"/>
           </a:xfrm>
           <a:prstGeom prst="rect">
@@ -9795,7 +10059,7 @@
         </p:nvSpPr>
         <p:spPr>
           <a:xfrm>
-            <a:off x="5541264" y="896112"/>
+            <a:off x="5152644" y="896112"/>
             <a:ext cx="1143000" cy="384048"/>
           </a:xfrm>
           <a:prstGeom prst="roundRect">
@@ -9822,7 +10086,7 @@
         </p:nvSpPr>
         <p:spPr>
           <a:xfrm>
-            <a:off x="5541264" y="896112"/>
+            <a:off x="5152644" y="896112"/>
             <a:ext cx="1143000" cy="384048"/>
           </a:xfrm>
           <a:prstGeom prst="rect">
@@ -9861,7 +10125,7 @@
         </p:nvSpPr>
         <p:spPr>
           <a:xfrm>
-            <a:off x="6775704" y="896112"/>
+            <a:off x="6387084" y="896112"/>
             <a:ext cx="1234440" cy="384048"/>
           </a:xfrm>
           <a:prstGeom prst="roundRect">
@@ -9888,7 +10152,7 @@
         </p:nvSpPr>
         <p:spPr>
           <a:xfrm>
-            <a:off x="6775704" y="896112"/>
+            <a:off x="6387084" y="896112"/>
             <a:ext cx="1234440" cy="384048"/>
           </a:xfrm>
           <a:prstGeom prst="rect">
@@ -9922,6 +10186,72 @@
       <p:sp>
         <p:nvSpPr>
           <p:cNvPr id="14" name="Shape 12"/>
+          <p:cNvSpPr/>
+          <p:nvPr/>
+        </p:nvSpPr>
+        <p:spPr>
+          <a:xfrm>
+            <a:off x="7712964" y="896112"/>
+            <a:ext cx="685800" cy="384048"/>
+          </a:xfrm>
+          <a:prstGeom prst="roundRect">
+            <a:avLst>
+              <a:gd name="adj" fmla="val 19048"/>
+            </a:avLst>
+          </a:prstGeom>
+          <a:solidFill>
+            <a:srgbClr val="262633"/>
+          </a:solidFill>
+          <a:ln w="12700">
+            <a:solidFill>
+              <a:srgbClr val="9A9AB0"/>
+            </a:solidFill>
+            <a:prstDash val="solid"/>
+          </a:ln>
+        </p:spPr>
+      </p:sp>
+      <p:sp>
+        <p:nvSpPr>
+          <p:cNvPr id="15" name="TimerResetBtn"/>
+          <p:cNvSpPr/>
+          <p:nvPr/>
+        </p:nvSpPr>
+        <p:spPr>
+          <a:xfrm>
+            <a:off x="7712964" y="896112"/>
+            <a:ext cx="685800" cy="384048"/>
+          </a:xfrm>
+          <a:prstGeom prst="rect">
+            <a:avLst/>
+          </a:prstGeom>
+          <a:noFill/>
+          <a:ln/>
+        </p:spPr>
+        <p:txBody>
+          <a:bodyPr wrap="square" lIns="0" tIns="0" rIns="0" bIns="0" rtlCol="0" anchor="ctr"/>
+          <a:lstStyle/>
+          <a:p>
+            <a:pPr algn="ctr" indent="0" marL="0">
+              <a:buNone/>
+            </a:pPr>
+            <a:r>
+              <a:rPr lang="en-US" sz="1100" b="1" dirty="0">
+                <a:solidFill>
+                  <a:srgbClr val="9A9AB0"/>
+                </a:solidFill>
+                <a:latin typeface="Calibri" pitchFamily="34" charset="0"/>
+                <a:ea typeface="Calibri" pitchFamily="34" charset="-122"/>
+                <a:cs typeface="Calibri" pitchFamily="34" charset="-120"/>
+              </a:rPr>
+              <a:t>RESET</a:t>
+            </a:r>
+            <a:endParaRPr lang="en-US" sz="1100" dirty="0"/>
+          </a:p>
+        </p:txBody>
+      </p:sp>
+      <p:sp>
+        <p:nvSpPr>
+          <p:cNvPr id="16" name="Shape 14"/>
           <p:cNvSpPr/>
           <p:nvPr/>
         </p:nvSpPr>
@@ -9948,7 +10278,7 @@
       </p:sp>
       <p:sp>
         <p:nvSpPr>
-          <p:cNvPr id="15" name="Text 13"/>
+          <p:cNvPr id="17" name="Text 15"/>
           <p:cNvSpPr/>
           <p:nvPr/>
         </p:nvSpPr>
@@ -9992,7 +10322,7 @@
       </p:sp>
       <p:sp>
         <p:nvSpPr>
-          <p:cNvPr id="16" name="Text 14"/>
+          <p:cNvPr id="18" name="Text 16"/>
           <p:cNvSpPr/>
           <p:nvPr/>
         </p:nvSpPr>
@@ -10031,7 +10361,7 @@
       </p:sp>
       <p:sp>
         <p:nvSpPr>
-          <p:cNvPr id="17" name="Text 15"/>
+          <p:cNvPr id="19" name="Text 17"/>
           <p:cNvSpPr/>
           <p:nvPr/>
         </p:nvSpPr>
@@ -11611,7 +11941,7 @@
         </p:nvSpPr>
         <p:spPr>
           <a:xfrm>
-            <a:off x="4178808" y="896112"/>
+            <a:off x="3790188" y="896112"/>
             <a:ext cx="310896" cy="384048"/>
           </a:xfrm>
           <a:prstGeom prst="rect">
@@ -11650,7 +11980,7 @@
         </p:nvSpPr>
         <p:spPr>
           <a:xfrm>
-            <a:off x="4581144" y="896112"/>
+            <a:off x="4192524" y="896112"/>
             <a:ext cx="868680" cy="384048"/>
           </a:xfrm>
           <a:prstGeom prst="roundRect">
@@ -11677,7 +12007,7 @@
         </p:nvSpPr>
         <p:spPr>
           <a:xfrm>
-            <a:off x="4581144" y="896112"/>
+            <a:off x="4192524" y="896112"/>
             <a:ext cx="868680" cy="384048"/>
           </a:xfrm>
           <a:prstGeom prst="rect">
@@ -11716,7 +12046,7 @@
         </p:nvSpPr>
         <p:spPr>
           <a:xfrm>
-            <a:off x="5541264" y="896112"/>
+            <a:off x="5152644" y="896112"/>
             <a:ext cx="1143000" cy="384048"/>
           </a:xfrm>
           <a:prstGeom prst="roundRect">
@@ -11743,7 +12073,7 @@
         </p:nvSpPr>
         <p:spPr>
           <a:xfrm>
-            <a:off x="5541264" y="896112"/>
+            <a:off x="5152644" y="896112"/>
             <a:ext cx="1143000" cy="384048"/>
           </a:xfrm>
           <a:prstGeom prst="rect">
@@ -11782,7 +12112,7 @@
         </p:nvSpPr>
         <p:spPr>
           <a:xfrm>
-            <a:off x="6775704" y="896112"/>
+            <a:off x="6387084" y="896112"/>
             <a:ext cx="1234440" cy="384048"/>
           </a:xfrm>
           <a:prstGeom prst="roundRect">
@@ -11809,7 +12139,7 @@
         </p:nvSpPr>
         <p:spPr>
           <a:xfrm>
-            <a:off x="6775704" y="896112"/>
+            <a:off x="6387084" y="896112"/>
             <a:ext cx="1234440" cy="384048"/>
           </a:xfrm>
           <a:prstGeom prst="rect">
@@ -11843,6 +12173,72 @@
       <p:sp>
         <p:nvSpPr>
           <p:cNvPr id="14" name="Shape 12"/>
+          <p:cNvSpPr/>
+          <p:nvPr/>
+        </p:nvSpPr>
+        <p:spPr>
+          <a:xfrm>
+            <a:off x="7712964" y="896112"/>
+            <a:ext cx="685800" cy="384048"/>
+          </a:xfrm>
+          <a:prstGeom prst="roundRect">
+            <a:avLst>
+              <a:gd name="adj" fmla="val 19048"/>
+            </a:avLst>
+          </a:prstGeom>
+          <a:solidFill>
+            <a:srgbClr val="262633"/>
+          </a:solidFill>
+          <a:ln w="12700">
+            <a:solidFill>
+              <a:srgbClr val="9A9AB0"/>
+            </a:solidFill>
+            <a:prstDash val="solid"/>
+          </a:ln>
+        </p:spPr>
+      </p:sp>
+      <p:sp>
+        <p:nvSpPr>
+          <p:cNvPr id="15" name="TimerResetBtn"/>
+          <p:cNvSpPr/>
+          <p:nvPr/>
+        </p:nvSpPr>
+        <p:spPr>
+          <a:xfrm>
+            <a:off x="7712964" y="896112"/>
+            <a:ext cx="685800" cy="384048"/>
+          </a:xfrm>
+          <a:prstGeom prst="rect">
+            <a:avLst/>
+          </a:prstGeom>
+          <a:noFill/>
+          <a:ln/>
+        </p:spPr>
+        <p:txBody>
+          <a:bodyPr wrap="square" lIns="0" tIns="0" rIns="0" bIns="0" rtlCol="0" anchor="ctr"/>
+          <a:lstStyle/>
+          <a:p>
+            <a:pPr algn="ctr" indent="0" marL="0">
+              <a:buNone/>
+            </a:pPr>
+            <a:r>
+              <a:rPr lang="en-US" sz="1100" b="1" dirty="0">
+                <a:solidFill>
+                  <a:srgbClr val="9A9AB0"/>
+                </a:solidFill>
+                <a:latin typeface="Calibri" pitchFamily="34" charset="0"/>
+                <a:ea typeface="Calibri" pitchFamily="34" charset="-122"/>
+                <a:cs typeface="Calibri" pitchFamily="34" charset="-120"/>
+              </a:rPr>
+              <a:t>RESET</a:t>
+            </a:r>
+            <a:endParaRPr lang="en-US" sz="1100" dirty="0"/>
+          </a:p>
+        </p:txBody>
+      </p:sp>
+      <p:sp>
+        <p:nvSpPr>
+          <p:cNvPr id="16" name="Shape 14"/>
           <p:cNvSpPr/>
           <p:nvPr/>
         </p:nvSpPr>
@@ -11869,7 +12265,7 @@
       </p:sp>
       <p:sp>
         <p:nvSpPr>
-          <p:cNvPr id="15" name="Text 13"/>
+          <p:cNvPr id="17" name="Text 15"/>
           <p:cNvSpPr/>
           <p:nvPr/>
         </p:nvSpPr>
@@ -11913,7 +12309,7 @@
       </p:sp>
       <p:sp>
         <p:nvSpPr>
-          <p:cNvPr id="16" name="Text 14"/>
+          <p:cNvPr id="18" name="Text 16"/>
           <p:cNvSpPr/>
           <p:nvPr/>
         </p:nvSpPr>
@@ -11952,7 +12348,7 @@
       </p:sp>
       <p:sp>
         <p:nvSpPr>
-          <p:cNvPr id="17" name="Text 15"/>
+          <p:cNvPr id="19" name="Text 17"/>
           <p:cNvSpPr/>
           <p:nvPr/>
         </p:nvSpPr>
@@ -12630,7 +13026,7 @@
         </p:nvSpPr>
         <p:spPr>
           <a:xfrm>
-            <a:off x="4178808" y="896112"/>
+            <a:off x="3790188" y="896112"/>
             <a:ext cx="310896" cy="384048"/>
           </a:xfrm>
           <a:prstGeom prst="rect">
@@ -12669,7 +13065,7 @@
         </p:nvSpPr>
         <p:spPr>
           <a:xfrm>
-            <a:off x="4581144" y="896112"/>
+            <a:off x="4192524" y="896112"/>
             <a:ext cx="868680" cy="384048"/>
           </a:xfrm>
           <a:prstGeom prst="roundRect">
@@ -12696,7 +13092,7 @@
         </p:nvSpPr>
         <p:spPr>
           <a:xfrm>
-            <a:off x="4581144" y="896112"/>
+            <a:off x="4192524" y="896112"/>
             <a:ext cx="868680" cy="384048"/>
           </a:xfrm>
           <a:prstGeom prst="rect">
@@ -12735,7 +13131,7 @@
         </p:nvSpPr>
         <p:spPr>
           <a:xfrm>
-            <a:off x="5541264" y="896112"/>
+            <a:off x="5152644" y="896112"/>
             <a:ext cx="1143000" cy="384048"/>
           </a:xfrm>
           <a:prstGeom prst="roundRect">
@@ -12762,7 +13158,7 @@
         </p:nvSpPr>
         <p:spPr>
           <a:xfrm>
-            <a:off x="5541264" y="896112"/>
+            <a:off x="5152644" y="896112"/>
             <a:ext cx="1143000" cy="384048"/>
           </a:xfrm>
           <a:prstGeom prst="rect">
@@ -12801,7 +13197,7 @@
         </p:nvSpPr>
         <p:spPr>
           <a:xfrm>
-            <a:off x="6775704" y="896112"/>
+            <a:off x="6387084" y="896112"/>
             <a:ext cx="1234440" cy="384048"/>
           </a:xfrm>
           <a:prstGeom prst="roundRect">
@@ -12828,7 +13224,7 @@
         </p:nvSpPr>
         <p:spPr>
           <a:xfrm>
-            <a:off x="6775704" y="896112"/>
+            <a:off x="6387084" y="896112"/>
             <a:ext cx="1234440" cy="384048"/>
           </a:xfrm>
           <a:prstGeom prst="rect">
@@ -12862,6 +13258,72 @@
       <p:sp>
         <p:nvSpPr>
           <p:cNvPr id="14" name="Shape 12"/>
+          <p:cNvSpPr/>
+          <p:nvPr/>
+        </p:nvSpPr>
+        <p:spPr>
+          <a:xfrm>
+            <a:off x="7712964" y="896112"/>
+            <a:ext cx="685800" cy="384048"/>
+          </a:xfrm>
+          <a:prstGeom prst="roundRect">
+            <a:avLst>
+              <a:gd name="adj" fmla="val 19048"/>
+            </a:avLst>
+          </a:prstGeom>
+          <a:solidFill>
+            <a:srgbClr val="262633"/>
+          </a:solidFill>
+          <a:ln w="12700">
+            <a:solidFill>
+              <a:srgbClr val="9A9AB0"/>
+            </a:solidFill>
+            <a:prstDash val="solid"/>
+          </a:ln>
+        </p:spPr>
+      </p:sp>
+      <p:sp>
+        <p:nvSpPr>
+          <p:cNvPr id="15" name="TimerResetBtn"/>
+          <p:cNvSpPr/>
+          <p:nvPr/>
+        </p:nvSpPr>
+        <p:spPr>
+          <a:xfrm>
+            <a:off x="7712964" y="896112"/>
+            <a:ext cx="685800" cy="384048"/>
+          </a:xfrm>
+          <a:prstGeom prst="rect">
+            <a:avLst/>
+          </a:prstGeom>
+          <a:noFill/>
+          <a:ln/>
+        </p:spPr>
+        <p:txBody>
+          <a:bodyPr wrap="square" lIns="0" tIns="0" rIns="0" bIns="0" rtlCol="0" anchor="ctr"/>
+          <a:lstStyle/>
+          <a:p>
+            <a:pPr algn="ctr" indent="0" marL="0">
+              <a:buNone/>
+            </a:pPr>
+            <a:r>
+              <a:rPr lang="en-US" sz="1100" b="1" dirty="0">
+                <a:solidFill>
+                  <a:srgbClr val="9A9AB0"/>
+                </a:solidFill>
+                <a:latin typeface="Calibri" pitchFamily="34" charset="0"/>
+                <a:ea typeface="Calibri" pitchFamily="34" charset="-122"/>
+                <a:cs typeface="Calibri" pitchFamily="34" charset="-120"/>
+              </a:rPr>
+              <a:t>RESET</a:t>
+            </a:r>
+            <a:endParaRPr lang="en-US" sz="1100" dirty="0"/>
+          </a:p>
+        </p:txBody>
+      </p:sp>
+      <p:sp>
+        <p:nvSpPr>
+          <p:cNvPr id="16" name="Shape 14"/>
           <p:cNvSpPr/>
           <p:nvPr/>
         </p:nvSpPr>
@@ -12888,7 +13350,7 @@
       </p:sp>
       <p:sp>
         <p:nvSpPr>
-          <p:cNvPr id="15" name="Text 13"/>
+          <p:cNvPr id="17" name="Text 15"/>
           <p:cNvSpPr/>
           <p:nvPr/>
         </p:nvSpPr>
@@ -12932,7 +13394,7 @@
       </p:sp>
       <p:sp>
         <p:nvSpPr>
-          <p:cNvPr id="16" name="Text 14"/>
+          <p:cNvPr id="18" name="Text 16"/>
           <p:cNvSpPr/>
           <p:nvPr/>
         </p:nvSpPr>
@@ -12971,7 +13433,7 @@
       </p:sp>
       <p:sp>
         <p:nvSpPr>
-          <p:cNvPr id="17" name="Text 15"/>
+          <p:cNvPr id="19" name="Text 17"/>
           <p:cNvSpPr/>
           <p:nvPr/>
         </p:nvSpPr>
@@ -13583,7 +14045,7 @@
         </p:nvSpPr>
         <p:spPr>
           <a:xfrm>
-            <a:off x="4178808" y="896112"/>
+            <a:off x="3790188" y="896112"/>
             <a:ext cx="310896" cy="384048"/>
           </a:xfrm>
           <a:prstGeom prst="rect">
@@ -13622,7 +14084,7 @@
         </p:nvSpPr>
         <p:spPr>
           <a:xfrm>
-            <a:off x="4581144" y="896112"/>
+            <a:off x="4192524" y="896112"/>
             <a:ext cx="868680" cy="384048"/>
           </a:xfrm>
           <a:prstGeom prst="roundRect">
@@ -13649,7 +14111,7 @@
         </p:nvSpPr>
         <p:spPr>
           <a:xfrm>
-            <a:off x="4581144" y="896112"/>
+            <a:off x="4192524" y="896112"/>
             <a:ext cx="868680" cy="384048"/>
           </a:xfrm>
           <a:prstGeom prst="rect">
@@ -13688,7 +14150,7 @@
         </p:nvSpPr>
         <p:spPr>
           <a:xfrm>
-            <a:off x="5541264" y="896112"/>
+            <a:off x="5152644" y="896112"/>
             <a:ext cx="1143000" cy="384048"/>
           </a:xfrm>
           <a:prstGeom prst="roundRect">
@@ -13715,7 +14177,7 @@
         </p:nvSpPr>
         <p:spPr>
           <a:xfrm>
-            <a:off x="5541264" y="896112"/>
+            <a:off x="5152644" y="896112"/>
             <a:ext cx="1143000" cy="384048"/>
           </a:xfrm>
           <a:prstGeom prst="rect">
@@ -13754,7 +14216,7 @@
         </p:nvSpPr>
         <p:spPr>
           <a:xfrm>
-            <a:off x="6775704" y="896112"/>
+            <a:off x="6387084" y="896112"/>
             <a:ext cx="1234440" cy="384048"/>
           </a:xfrm>
           <a:prstGeom prst="roundRect">
@@ -13781,7 +14243,7 @@
         </p:nvSpPr>
         <p:spPr>
           <a:xfrm>
-            <a:off x="6775704" y="896112"/>
+            <a:off x="6387084" y="896112"/>
             <a:ext cx="1234440" cy="384048"/>
           </a:xfrm>
           <a:prstGeom prst="rect">
@@ -13815,6 +14277,72 @@
       <p:sp>
         <p:nvSpPr>
           <p:cNvPr id="14" name="Shape 12"/>
+          <p:cNvSpPr/>
+          <p:nvPr/>
+        </p:nvSpPr>
+        <p:spPr>
+          <a:xfrm>
+            <a:off x="7712964" y="896112"/>
+            <a:ext cx="685800" cy="384048"/>
+          </a:xfrm>
+          <a:prstGeom prst="roundRect">
+            <a:avLst>
+              <a:gd name="adj" fmla="val 19048"/>
+            </a:avLst>
+          </a:prstGeom>
+          <a:solidFill>
+            <a:srgbClr val="262633"/>
+          </a:solidFill>
+          <a:ln w="12700">
+            <a:solidFill>
+              <a:srgbClr val="9A9AB0"/>
+            </a:solidFill>
+            <a:prstDash val="solid"/>
+          </a:ln>
+        </p:spPr>
+      </p:sp>
+      <p:sp>
+        <p:nvSpPr>
+          <p:cNvPr id="15" name="TimerResetBtn"/>
+          <p:cNvSpPr/>
+          <p:nvPr/>
+        </p:nvSpPr>
+        <p:spPr>
+          <a:xfrm>
+            <a:off x="7712964" y="896112"/>
+            <a:ext cx="685800" cy="384048"/>
+          </a:xfrm>
+          <a:prstGeom prst="rect">
+            <a:avLst/>
+          </a:prstGeom>
+          <a:noFill/>
+          <a:ln/>
+        </p:spPr>
+        <p:txBody>
+          <a:bodyPr wrap="square" lIns="0" tIns="0" rIns="0" bIns="0" rtlCol="0" anchor="ctr"/>
+          <a:lstStyle/>
+          <a:p>
+            <a:pPr algn="ctr" indent="0" marL="0">
+              <a:buNone/>
+            </a:pPr>
+            <a:r>
+              <a:rPr lang="en-US" sz="1100" b="1" dirty="0">
+                <a:solidFill>
+                  <a:srgbClr val="9A9AB0"/>
+                </a:solidFill>
+                <a:latin typeface="Calibri" pitchFamily="34" charset="0"/>
+                <a:ea typeface="Calibri" pitchFamily="34" charset="-122"/>
+                <a:cs typeface="Calibri" pitchFamily="34" charset="-120"/>
+              </a:rPr>
+              <a:t>RESET</a:t>
+            </a:r>
+            <a:endParaRPr lang="en-US" sz="1100" dirty="0"/>
+          </a:p>
+        </p:txBody>
+      </p:sp>
+      <p:sp>
+        <p:nvSpPr>
+          <p:cNvPr id="16" name="Shape 14"/>
           <p:cNvSpPr/>
           <p:nvPr/>
         </p:nvSpPr>
@@ -13841,7 +14369,7 @@
       </p:sp>
       <p:sp>
         <p:nvSpPr>
-          <p:cNvPr id="15" name="Text 13"/>
+          <p:cNvPr id="17" name="Text 15"/>
           <p:cNvSpPr/>
           <p:nvPr/>
         </p:nvSpPr>
@@ -13885,7 +14413,7 @@
       </p:sp>
       <p:sp>
         <p:nvSpPr>
-          <p:cNvPr id="16" name="Text 14"/>
+          <p:cNvPr id="18" name="Text 16"/>
           <p:cNvSpPr/>
           <p:nvPr/>
         </p:nvSpPr>
@@ -13924,7 +14452,7 @@
       </p:sp>
       <p:sp>
         <p:nvSpPr>
-          <p:cNvPr id="17" name="Text 15"/>
+          <p:cNvPr id="19" name="Text 17"/>
           <p:cNvSpPr/>
           <p:nvPr/>
         </p:nvSpPr>
@@ -16049,7 +16577,7 @@
         </p:nvSpPr>
         <p:spPr>
           <a:xfrm>
-            <a:off x="4178808" y="896112"/>
+            <a:off x="3790188" y="896112"/>
             <a:ext cx="310896" cy="384048"/>
           </a:xfrm>
           <a:prstGeom prst="rect">
@@ -16088,7 +16616,7 @@
         </p:nvSpPr>
         <p:spPr>
           <a:xfrm>
-            <a:off x="4581144" y="896112"/>
+            <a:off x="4192524" y="896112"/>
             <a:ext cx="868680" cy="384048"/>
           </a:xfrm>
           <a:prstGeom prst="roundRect">
@@ -16115,7 +16643,7 @@
         </p:nvSpPr>
         <p:spPr>
           <a:xfrm>
-            <a:off x="4581144" y="896112"/>
+            <a:off x="4192524" y="896112"/>
             <a:ext cx="868680" cy="384048"/>
           </a:xfrm>
           <a:prstGeom prst="rect">
@@ -16154,7 +16682,7 @@
         </p:nvSpPr>
         <p:spPr>
           <a:xfrm>
-            <a:off x="5541264" y="896112"/>
+            <a:off x="5152644" y="896112"/>
             <a:ext cx="1143000" cy="384048"/>
           </a:xfrm>
           <a:prstGeom prst="roundRect">
@@ -16181,7 +16709,7 @@
         </p:nvSpPr>
         <p:spPr>
           <a:xfrm>
-            <a:off x="5541264" y="896112"/>
+            <a:off x="5152644" y="896112"/>
             <a:ext cx="1143000" cy="384048"/>
           </a:xfrm>
           <a:prstGeom prst="rect">
@@ -16220,7 +16748,7 @@
         </p:nvSpPr>
         <p:spPr>
           <a:xfrm>
-            <a:off x="6775704" y="896112"/>
+            <a:off x="6387084" y="896112"/>
             <a:ext cx="1234440" cy="384048"/>
           </a:xfrm>
           <a:prstGeom prst="roundRect">
@@ -16247,7 +16775,7 @@
         </p:nvSpPr>
         <p:spPr>
           <a:xfrm>
-            <a:off x="6775704" y="896112"/>
+            <a:off x="6387084" y="896112"/>
             <a:ext cx="1234440" cy="384048"/>
           </a:xfrm>
           <a:prstGeom prst="rect">
@@ -16281,6 +16809,72 @@
       <p:sp>
         <p:nvSpPr>
           <p:cNvPr id="14" name="Shape 12"/>
+          <p:cNvSpPr/>
+          <p:nvPr/>
+        </p:nvSpPr>
+        <p:spPr>
+          <a:xfrm>
+            <a:off x="7712964" y="896112"/>
+            <a:ext cx="685800" cy="384048"/>
+          </a:xfrm>
+          <a:prstGeom prst="roundRect">
+            <a:avLst>
+              <a:gd name="adj" fmla="val 19048"/>
+            </a:avLst>
+          </a:prstGeom>
+          <a:solidFill>
+            <a:srgbClr val="262633"/>
+          </a:solidFill>
+          <a:ln w="12700">
+            <a:solidFill>
+              <a:srgbClr val="9A9AB0"/>
+            </a:solidFill>
+            <a:prstDash val="solid"/>
+          </a:ln>
+        </p:spPr>
+      </p:sp>
+      <p:sp>
+        <p:nvSpPr>
+          <p:cNvPr id="15" name="TimerResetBtn"/>
+          <p:cNvSpPr/>
+          <p:nvPr/>
+        </p:nvSpPr>
+        <p:spPr>
+          <a:xfrm>
+            <a:off x="7712964" y="896112"/>
+            <a:ext cx="685800" cy="384048"/>
+          </a:xfrm>
+          <a:prstGeom prst="rect">
+            <a:avLst/>
+          </a:prstGeom>
+          <a:noFill/>
+          <a:ln/>
+        </p:spPr>
+        <p:txBody>
+          <a:bodyPr wrap="square" lIns="0" tIns="0" rIns="0" bIns="0" rtlCol="0" anchor="ctr"/>
+          <a:lstStyle/>
+          <a:p>
+            <a:pPr algn="ctr" indent="0" marL="0">
+              <a:buNone/>
+            </a:pPr>
+            <a:r>
+              <a:rPr lang="en-US" sz="1100" b="1" dirty="0">
+                <a:solidFill>
+                  <a:srgbClr val="9A9AB0"/>
+                </a:solidFill>
+                <a:latin typeface="Calibri" pitchFamily="34" charset="0"/>
+                <a:ea typeface="Calibri" pitchFamily="34" charset="-122"/>
+                <a:cs typeface="Calibri" pitchFamily="34" charset="-120"/>
+              </a:rPr>
+              <a:t>RESET</a:t>
+            </a:r>
+            <a:endParaRPr lang="en-US" sz="1100" dirty="0"/>
+          </a:p>
+        </p:txBody>
+      </p:sp>
+      <p:sp>
+        <p:nvSpPr>
+          <p:cNvPr id="16" name="Shape 14"/>
           <p:cNvSpPr/>
           <p:nvPr/>
         </p:nvSpPr>
@@ -16307,7 +16901,7 @@
       </p:sp>
       <p:sp>
         <p:nvSpPr>
-          <p:cNvPr id="15" name="Text 13"/>
+          <p:cNvPr id="17" name="Text 15"/>
           <p:cNvSpPr/>
           <p:nvPr/>
         </p:nvSpPr>
@@ -16351,7 +16945,7 @@
       </p:sp>
       <p:sp>
         <p:nvSpPr>
-          <p:cNvPr id="16" name="Text 14"/>
+          <p:cNvPr id="18" name="Text 16"/>
           <p:cNvSpPr/>
           <p:nvPr/>
         </p:nvSpPr>
@@ -16390,7 +16984,7 @@
       </p:sp>
       <p:sp>
         <p:nvSpPr>
-          <p:cNvPr id="17" name="Text 15"/>
+          <p:cNvPr id="19" name="Text 17"/>
           <p:cNvSpPr/>
           <p:nvPr/>
         </p:nvSpPr>
@@ -17245,7 +17839,7 @@
                 <a:ea typeface="Calibri" pitchFamily="34" charset="-122"/>
                 <a:cs typeface="Calibri" pitchFamily="34" charset="-120"/>
               </a:rPr>
-              <a:t>Insert → Module, then paste in the timer macro code (provided separately).</a:t>
+              <a:t>Import the two provided macro files: File → Import File… for PhysicsLeagueTimer.bas and again for PhysicsLeagueTimerEvents.cls.</a:t>
             </a:r>
             <a:endParaRPr lang="en-US" sz="1900" dirty="0"/>
           </a:p>
@@ -17285,7 +17879,7 @@
                 <a:ea typeface="Calibri" pitchFamily="34" charset="-122"/>
                 <a:cs typeface="Calibri" pitchFamily="34" charset="-120"/>
               </a:rPr>
-              <a:t>Click into the module and press F5 to run “SetupTimerButtons” — once. A message box confirms how many buttons were wired.</a:t>
+              <a:t>Double-click “ThisPresentation” in the project tree and paste in the short startup snippet (provided separately).</a:t>
             </a:r>
             <a:endParaRPr lang="en-US" sz="1900" dirty="0"/>
           </a:p>
@@ -17325,6 +17919,46 @@
                 <a:ea typeface="Calibri" pitchFamily="34" charset="-122"/>
                 <a:cs typeface="Calibri" pitchFamily="34" charset="-120"/>
               </a:rPr>
+              <a:t>Click into PhysicsLeagueTimer.bas and press F5 to run “SetupTimerButtons” — once. A message box confirms how many buttons were wired.</a:t>
+            </a:r>
+            <a:endParaRPr lang="en-US" sz="1900" dirty="0"/>
+          </a:p>
+          <a:p>
+            <a:pPr algn="l" indent="0" marL="0">
+              <a:lnSpc>
+                <a:spcPct val="125000"/>
+              </a:lnSpc>
+              <a:buNone/>
+            </a:pPr>
+            <a:r>
+              <a:rPr lang="en-US" sz="1900" b="1" dirty="0">
+                <a:solidFill>
+                  <a:srgbClr val="FFD24A"/>
+                </a:solidFill>
+                <a:latin typeface="Calibri" pitchFamily="34" charset="0"/>
+                <a:ea typeface="Calibri" pitchFamily="34" charset="-122"/>
+                <a:cs typeface="Calibri" pitchFamily="34" charset="-120"/>
+              </a:rPr>
+              <a:t>6.  </a:t>
+            </a:r>
+            <a:pPr algn="l" indent="0" marL="0">
+              <a:lnSpc>
+                <a:spcPct val="125000"/>
+              </a:lnSpc>
+              <a:spcAft>
+                <a:spcPts val="1600"/>
+              </a:spcAft>
+              <a:buNone/>
+            </a:pPr>
+            <a:r>
+              <a:rPr lang="en-US" sz="1900" dirty="0">
+                <a:solidFill>
+                  <a:srgbClr val="F2F2F7"/>
+                </a:solidFill>
+                <a:latin typeface="Calibri" pitchFamily="34" charset="0"/>
+                <a:ea typeface="Calibri" pitchFamily="34" charset="-122"/>
+                <a:cs typeface="Calibri" pitchFamily="34" charset="-120"/>
+              </a:rPr>
               <a:t>Save and close the VBA editor. When you reopen the file later, click “Enable Content” to allow macros.</a:t>
             </a:r>
             <a:endParaRPr lang="en-US" sz="1900" dirty="0"/>
@@ -17364,7 +17998,7 @@
                 <a:ea typeface="Calibri" pitchFamily="34" charset="-122"/>
                 <a:cs typeface="Calibri" pitchFamily="34" charset="-120"/>
               </a:rPr>
-              <a:t>On each question slide: edit the small time box if you want a different limit, then click ▶ START to run the countdown live.</a:t>
+              <a:t>On each question slide: edit the time box if needed, click ▶ START to run the countdown, or RESET to restore the original time. A finished timer resets itself automatically when you leave and return to its slide.</a:t>
             </a:r>
             <a:endParaRPr lang="en-US" sz="1400" dirty="0"/>
           </a:p>
@@ -17659,7 +18293,7 @@
         </p:nvSpPr>
         <p:spPr>
           <a:xfrm>
-            <a:off x="4178808" y="896112"/>
+            <a:off x="3790188" y="896112"/>
             <a:ext cx="310896" cy="384048"/>
           </a:xfrm>
           <a:prstGeom prst="rect">
@@ -17698,7 +18332,7 @@
         </p:nvSpPr>
         <p:spPr>
           <a:xfrm>
-            <a:off x="4581144" y="896112"/>
+            <a:off x="4192524" y="896112"/>
             <a:ext cx="868680" cy="384048"/>
           </a:xfrm>
           <a:prstGeom prst="roundRect">
@@ -17725,7 +18359,7 @@
         </p:nvSpPr>
         <p:spPr>
           <a:xfrm>
-            <a:off x="4581144" y="896112"/>
+            <a:off x="4192524" y="896112"/>
             <a:ext cx="868680" cy="384048"/>
           </a:xfrm>
           <a:prstGeom prst="rect">
@@ -17764,7 +18398,7 @@
         </p:nvSpPr>
         <p:spPr>
           <a:xfrm>
-            <a:off x="5541264" y="896112"/>
+            <a:off x="5152644" y="896112"/>
             <a:ext cx="1143000" cy="384048"/>
           </a:xfrm>
           <a:prstGeom prst="roundRect">
@@ -17791,7 +18425,7 @@
         </p:nvSpPr>
         <p:spPr>
           <a:xfrm>
-            <a:off x="5541264" y="896112"/>
+            <a:off x="5152644" y="896112"/>
             <a:ext cx="1143000" cy="384048"/>
           </a:xfrm>
           <a:prstGeom prst="rect">
@@ -17830,7 +18464,7 @@
         </p:nvSpPr>
         <p:spPr>
           <a:xfrm>
-            <a:off x="6775704" y="896112"/>
+            <a:off x="6387084" y="896112"/>
             <a:ext cx="1234440" cy="384048"/>
           </a:xfrm>
           <a:prstGeom prst="roundRect">
@@ -17857,7 +18491,7 @@
         </p:nvSpPr>
         <p:spPr>
           <a:xfrm>
-            <a:off x="6775704" y="896112"/>
+            <a:off x="6387084" y="896112"/>
             <a:ext cx="1234440" cy="384048"/>
           </a:xfrm>
           <a:prstGeom prst="rect">
@@ -17891,6 +18525,72 @@
       <p:sp>
         <p:nvSpPr>
           <p:cNvPr id="14" name="Shape 12"/>
+          <p:cNvSpPr/>
+          <p:nvPr/>
+        </p:nvSpPr>
+        <p:spPr>
+          <a:xfrm>
+            <a:off x="7712964" y="896112"/>
+            <a:ext cx="685800" cy="384048"/>
+          </a:xfrm>
+          <a:prstGeom prst="roundRect">
+            <a:avLst>
+              <a:gd name="adj" fmla="val 19048"/>
+            </a:avLst>
+          </a:prstGeom>
+          <a:solidFill>
+            <a:srgbClr val="262633"/>
+          </a:solidFill>
+          <a:ln w="12700">
+            <a:solidFill>
+              <a:srgbClr val="9A9AB0"/>
+            </a:solidFill>
+            <a:prstDash val="solid"/>
+          </a:ln>
+        </p:spPr>
+      </p:sp>
+      <p:sp>
+        <p:nvSpPr>
+          <p:cNvPr id="15" name="TimerResetBtn"/>
+          <p:cNvSpPr/>
+          <p:nvPr/>
+        </p:nvSpPr>
+        <p:spPr>
+          <a:xfrm>
+            <a:off x="7712964" y="896112"/>
+            <a:ext cx="685800" cy="384048"/>
+          </a:xfrm>
+          <a:prstGeom prst="rect">
+            <a:avLst/>
+          </a:prstGeom>
+          <a:noFill/>
+          <a:ln/>
+        </p:spPr>
+        <p:txBody>
+          <a:bodyPr wrap="square" lIns="0" tIns="0" rIns="0" bIns="0" rtlCol="0" anchor="ctr"/>
+          <a:lstStyle/>
+          <a:p>
+            <a:pPr algn="ctr" indent="0" marL="0">
+              <a:buNone/>
+            </a:pPr>
+            <a:r>
+              <a:rPr lang="en-US" sz="1100" b="1" dirty="0">
+                <a:solidFill>
+                  <a:srgbClr val="9A9AB0"/>
+                </a:solidFill>
+                <a:latin typeface="Calibri" pitchFamily="34" charset="0"/>
+                <a:ea typeface="Calibri" pitchFamily="34" charset="-122"/>
+                <a:cs typeface="Calibri" pitchFamily="34" charset="-120"/>
+              </a:rPr>
+              <a:t>RESET</a:t>
+            </a:r>
+            <a:endParaRPr lang="en-US" sz="1100" dirty="0"/>
+          </a:p>
+        </p:txBody>
+      </p:sp>
+      <p:sp>
+        <p:nvSpPr>
+          <p:cNvPr id="16" name="Shape 14"/>
           <p:cNvSpPr/>
           <p:nvPr/>
         </p:nvSpPr>
@@ -17917,7 +18617,7 @@
       </p:sp>
       <p:sp>
         <p:nvSpPr>
-          <p:cNvPr id="15" name="Text 13"/>
+          <p:cNvPr id="17" name="Text 15"/>
           <p:cNvSpPr/>
           <p:nvPr/>
         </p:nvSpPr>
@@ -17961,7 +18661,7 @@
       </p:sp>
       <p:sp>
         <p:nvSpPr>
-          <p:cNvPr id="16" name="Text 14"/>
+          <p:cNvPr id="18" name="Text 16"/>
           <p:cNvSpPr/>
           <p:nvPr/>
         </p:nvSpPr>
@@ -18000,7 +18700,7 @@
       </p:sp>
       <p:sp>
         <p:nvSpPr>
-          <p:cNvPr id="17" name="Text 15"/>
+          <p:cNvPr id="19" name="Text 17"/>
           <p:cNvSpPr/>
           <p:nvPr/>
         </p:nvSpPr>
@@ -18938,7 +19638,7 @@
         </p:nvSpPr>
         <p:spPr>
           <a:xfrm>
-            <a:off x="4178808" y="896112"/>
+            <a:off x="3790188" y="896112"/>
             <a:ext cx="310896" cy="384048"/>
           </a:xfrm>
           <a:prstGeom prst="rect">
@@ -18977,7 +19677,7 @@
         </p:nvSpPr>
         <p:spPr>
           <a:xfrm>
-            <a:off x="4581144" y="896112"/>
+            <a:off x="4192524" y="896112"/>
             <a:ext cx="868680" cy="384048"/>
           </a:xfrm>
           <a:prstGeom prst="roundRect">
@@ -19004,7 +19704,7 @@
         </p:nvSpPr>
         <p:spPr>
           <a:xfrm>
-            <a:off x="4581144" y="896112"/>
+            <a:off x="4192524" y="896112"/>
             <a:ext cx="868680" cy="384048"/>
           </a:xfrm>
           <a:prstGeom prst="rect">
@@ -19043,7 +19743,7 @@
         </p:nvSpPr>
         <p:spPr>
           <a:xfrm>
-            <a:off x="5541264" y="896112"/>
+            <a:off x="5152644" y="896112"/>
             <a:ext cx="1143000" cy="384048"/>
           </a:xfrm>
           <a:prstGeom prst="roundRect">
@@ -19070,7 +19770,7 @@
         </p:nvSpPr>
         <p:spPr>
           <a:xfrm>
-            <a:off x="5541264" y="896112"/>
+            <a:off x="5152644" y="896112"/>
             <a:ext cx="1143000" cy="384048"/>
           </a:xfrm>
           <a:prstGeom prst="rect">
@@ -19109,7 +19809,7 @@
         </p:nvSpPr>
         <p:spPr>
           <a:xfrm>
-            <a:off x="6775704" y="896112"/>
+            <a:off x="6387084" y="896112"/>
             <a:ext cx="1234440" cy="384048"/>
           </a:xfrm>
           <a:prstGeom prst="roundRect">
@@ -19136,7 +19836,7 @@
         </p:nvSpPr>
         <p:spPr>
           <a:xfrm>
-            <a:off x="6775704" y="896112"/>
+            <a:off x="6387084" y="896112"/>
             <a:ext cx="1234440" cy="384048"/>
           </a:xfrm>
           <a:prstGeom prst="rect">
@@ -19170,6 +19870,72 @@
       <p:sp>
         <p:nvSpPr>
           <p:cNvPr id="14" name="Shape 12"/>
+          <p:cNvSpPr/>
+          <p:nvPr/>
+        </p:nvSpPr>
+        <p:spPr>
+          <a:xfrm>
+            <a:off x="7712964" y="896112"/>
+            <a:ext cx="685800" cy="384048"/>
+          </a:xfrm>
+          <a:prstGeom prst="roundRect">
+            <a:avLst>
+              <a:gd name="adj" fmla="val 19048"/>
+            </a:avLst>
+          </a:prstGeom>
+          <a:solidFill>
+            <a:srgbClr val="262633"/>
+          </a:solidFill>
+          <a:ln w="12700">
+            <a:solidFill>
+              <a:srgbClr val="9A9AB0"/>
+            </a:solidFill>
+            <a:prstDash val="solid"/>
+          </a:ln>
+        </p:spPr>
+      </p:sp>
+      <p:sp>
+        <p:nvSpPr>
+          <p:cNvPr id="15" name="TimerResetBtn"/>
+          <p:cNvSpPr/>
+          <p:nvPr/>
+        </p:nvSpPr>
+        <p:spPr>
+          <a:xfrm>
+            <a:off x="7712964" y="896112"/>
+            <a:ext cx="685800" cy="384048"/>
+          </a:xfrm>
+          <a:prstGeom prst="rect">
+            <a:avLst/>
+          </a:prstGeom>
+          <a:noFill/>
+          <a:ln/>
+        </p:spPr>
+        <p:txBody>
+          <a:bodyPr wrap="square" lIns="0" tIns="0" rIns="0" bIns="0" rtlCol="0" anchor="ctr"/>
+          <a:lstStyle/>
+          <a:p>
+            <a:pPr algn="ctr" indent="0" marL="0">
+              <a:buNone/>
+            </a:pPr>
+            <a:r>
+              <a:rPr lang="en-US" sz="1100" b="1" dirty="0">
+                <a:solidFill>
+                  <a:srgbClr val="9A9AB0"/>
+                </a:solidFill>
+                <a:latin typeface="Calibri" pitchFamily="34" charset="0"/>
+                <a:ea typeface="Calibri" pitchFamily="34" charset="-122"/>
+                <a:cs typeface="Calibri" pitchFamily="34" charset="-120"/>
+              </a:rPr>
+              <a:t>RESET</a:t>
+            </a:r>
+            <a:endParaRPr lang="en-US" sz="1100" dirty="0"/>
+          </a:p>
+        </p:txBody>
+      </p:sp>
+      <p:sp>
+        <p:nvSpPr>
+          <p:cNvPr id="16" name="Shape 14"/>
           <p:cNvSpPr/>
           <p:nvPr/>
         </p:nvSpPr>
@@ -19196,7 +19962,7 @@
       </p:sp>
       <p:sp>
         <p:nvSpPr>
-          <p:cNvPr id="15" name="Text 13"/>
+          <p:cNvPr id="17" name="Text 15"/>
           <p:cNvSpPr/>
           <p:nvPr/>
         </p:nvSpPr>
@@ -19240,7 +20006,7 @@
       </p:sp>
       <p:sp>
         <p:nvSpPr>
-          <p:cNvPr id="16" name="Text 14"/>
+          <p:cNvPr id="18" name="Text 16"/>
           <p:cNvSpPr/>
           <p:nvPr/>
         </p:nvSpPr>
@@ -19279,7 +20045,7 @@
       </p:sp>
       <p:sp>
         <p:nvSpPr>
-          <p:cNvPr id="17" name="Text 15"/>
+          <p:cNvPr id="19" name="Text 17"/>
           <p:cNvSpPr/>
           <p:nvPr/>
         </p:nvSpPr>
@@ -20151,7 +20917,7 @@
         </p:nvSpPr>
         <p:spPr>
           <a:xfrm>
-            <a:off x="4178808" y="896112"/>
+            <a:off x="3790188" y="896112"/>
             <a:ext cx="310896" cy="384048"/>
           </a:xfrm>
           <a:prstGeom prst="rect">
@@ -20190,7 +20956,7 @@
         </p:nvSpPr>
         <p:spPr>
           <a:xfrm>
-            <a:off x="4581144" y="896112"/>
+            <a:off x="4192524" y="896112"/>
             <a:ext cx="868680" cy="384048"/>
           </a:xfrm>
           <a:prstGeom prst="roundRect">
@@ -20217,7 +20983,7 @@
         </p:nvSpPr>
         <p:spPr>
           <a:xfrm>
-            <a:off x="4581144" y="896112"/>
+            <a:off x="4192524" y="896112"/>
             <a:ext cx="868680" cy="384048"/>
           </a:xfrm>
           <a:prstGeom prst="rect">
@@ -20256,7 +21022,7 @@
         </p:nvSpPr>
         <p:spPr>
           <a:xfrm>
-            <a:off x="5541264" y="896112"/>
+            <a:off x="5152644" y="896112"/>
             <a:ext cx="1143000" cy="384048"/>
           </a:xfrm>
           <a:prstGeom prst="roundRect">
@@ -20283,7 +21049,7 @@
         </p:nvSpPr>
         <p:spPr>
           <a:xfrm>
-            <a:off x="5541264" y="896112"/>
+            <a:off x="5152644" y="896112"/>
             <a:ext cx="1143000" cy="384048"/>
           </a:xfrm>
           <a:prstGeom prst="rect">
@@ -20322,7 +21088,7 @@
         </p:nvSpPr>
         <p:spPr>
           <a:xfrm>
-            <a:off x="6775704" y="896112"/>
+            <a:off x="6387084" y="896112"/>
             <a:ext cx="1234440" cy="384048"/>
           </a:xfrm>
           <a:prstGeom prst="roundRect">
@@ -20349,7 +21115,7 @@
         </p:nvSpPr>
         <p:spPr>
           <a:xfrm>
-            <a:off x="6775704" y="896112"/>
+            <a:off x="6387084" y="896112"/>
             <a:ext cx="1234440" cy="384048"/>
           </a:xfrm>
           <a:prstGeom prst="rect">
@@ -20383,6 +21149,72 @@
       <p:sp>
         <p:nvSpPr>
           <p:cNvPr id="14" name="Shape 12"/>
+          <p:cNvSpPr/>
+          <p:nvPr/>
+        </p:nvSpPr>
+        <p:spPr>
+          <a:xfrm>
+            <a:off x="7712964" y="896112"/>
+            <a:ext cx="685800" cy="384048"/>
+          </a:xfrm>
+          <a:prstGeom prst="roundRect">
+            <a:avLst>
+              <a:gd name="adj" fmla="val 19048"/>
+            </a:avLst>
+          </a:prstGeom>
+          <a:solidFill>
+            <a:srgbClr val="262633"/>
+          </a:solidFill>
+          <a:ln w="12700">
+            <a:solidFill>
+              <a:srgbClr val="9A9AB0"/>
+            </a:solidFill>
+            <a:prstDash val="solid"/>
+          </a:ln>
+        </p:spPr>
+      </p:sp>
+      <p:sp>
+        <p:nvSpPr>
+          <p:cNvPr id="15" name="TimerResetBtn"/>
+          <p:cNvSpPr/>
+          <p:nvPr/>
+        </p:nvSpPr>
+        <p:spPr>
+          <a:xfrm>
+            <a:off x="7712964" y="896112"/>
+            <a:ext cx="685800" cy="384048"/>
+          </a:xfrm>
+          <a:prstGeom prst="rect">
+            <a:avLst/>
+          </a:prstGeom>
+          <a:noFill/>
+          <a:ln/>
+        </p:spPr>
+        <p:txBody>
+          <a:bodyPr wrap="square" lIns="0" tIns="0" rIns="0" bIns="0" rtlCol="0" anchor="ctr"/>
+          <a:lstStyle/>
+          <a:p>
+            <a:pPr algn="ctr" indent="0" marL="0">
+              <a:buNone/>
+            </a:pPr>
+            <a:r>
+              <a:rPr lang="en-US" sz="1100" b="1" dirty="0">
+                <a:solidFill>
+                  <a:srgbClr val="9A9AB0"/>
+                </a:solidFill>
+                <a:latin typeface="Calibri" pitchFamily="34" charset="0"/>
+                <a:ea typeface="Calibri" pitchFamily="34" charset="-122"/>
+                <a:cs typeface="Calibri" pitchFamily="34" charset="-120"/>
+              </a:rPr>
+              <a:t>RESET</a:t>
+            </a:r>
+            <a:endParaRPr lang="en-US" sz="1100" dirty="0"/>
+          </a:p>
+        </p:txBody>
+      </p:sp>
+      <p:sp>
+        <p:nvSpPr>
+          <p:cNvPr id="16" name="Shape 14"/>
           <p:cNvSpPr/>
           <p:nvPr/>
         </p:nvSpPr>
@@ -20409,7 +21241,7 @@
       </p:sp>
       <p:sp>
         <p:nvSpPr>
-          <p:cNvPr id="15" name="Text 13"/>
+          <p:cNvPr id="17" name="Text 15"/>
           <p:cNvSpPr/>
           <p:nvPr/>
         </p:nvSpPr>
@@ -20453,7 +21285,7 @@
       </p:sp>
       <p:sp>
         <p:nvSpPr>
-          <p:cNvPr id="16" name="Text 14"/>
+          <p:cNvPr id="18" name="Text 16"/>
           <p:cNvSpPr/>
           <p:nvPr/>
         </p:nvSpPr>
@@ -20492,7 +21324,7 @@
       </p:sp>
       <p:sp>
         <p:nvSpPr>
-          <p:cNvPr id="17" name="Text 15"/>
+          <p:cNvPr id="19" name="Text 17"/>
           <p:cNvSpPr/>
           <p:nvPr/>
         </p:nvSpPr>
@@ -21204,7 +22036,7 @@
         </p:nvSpPr>
         <p:spPr>
           <a:xfrm>
-            <a:off x="4178808" y="896112"/>
+            <a:off x="3790188" y="896112"/>
             <a:ext cx="310896" cy="384048"/>
           </a:xfrm>
           <a:prstGeom prst="rect">
@@ -21243,7 +22075,7 @@
         </p:nvSpPr>
         <p:spPr>
           <a:xfrm>
-            <a:off x="4581144" y="896112"/>
+            <a:off x="4192524" y="896112"/>
             <a:ext cx="868680" cy="384048"/>
           </a:xfrm>
           <a:prstGeom prst="roundRect">
@@ -21270,7 +22102,7 @@
         </p:nvSpPr>
         <p:spPr>
           <a:xfrm>
-            <a:off x="4581144" y="896112"/>
+            <a:off x="4192524" y="896112"/>
             <a:ext cx="868680" cy="384048"/>
           </a:xfrm>
           <a:prstGeom prst="rect">
@@ -21309,7 +22141,7 @@
         </p:nvSpPr>
         <p:spPr>
           <a:xfrm>
-            <a:off x="5541264" y="896112"/>
+            <a:off x="5152644" y="896112"/>
             <a:ext cx="1143000" cy="384048"/>
           </a:xfrm>
           <a:prstGeom prst="roundRect">
@@ -21336,7 +22168,7 @@
         </p:nvSpPr>
         <p:spPr>
           <a:xfrm>
-            <a:off x="5541264" y="896112"/>
+            <a:off x="5152644" y="896112"/>
             <a:ext cx="1143000" cy="384048"/>
           </a:xfrm>
           <a:prstGeom prst="rect">
@@ -21375,7 +22207,7 @@
         </p:nvSpPr>
         <p:spPr>
           <a:xfrm>
-            <a:off x="6775704" y="896112"/>
+            <a:off x="6387084" y="896112"/>
             <a:ext cx="1234440" cy="384048"/>
           </a:xfrm>
           <a:prstGeom prst="roundRect">
@@ -21402,7 +22234,7 @@
         </p:nvSpPr>
         <p:spPr>
           <a:xfrm>
-            <a:off x="6775704" y="896112"/>
+            <a:off x="6387084" y="896112"/>
             <a:ext cx="1234440" cy="384048"/>
           </a:xfrm>
           <a:prstGeom prst="rect">
@@ -21436,6 +22268,72 @@
       <p:sp>
         <p:nvSpPr>
           <p:cNvPr id="14" name="Shape 12"/>
+          <p:cNvSpPr/>
+          <p:nvPr/>
+        </p:nvSpPr>
+        <p:spPr>
+          <a:xfrm>
+            <a:off x="7712964" y="896112"/>
+            <a:ext cx="685800" cy="384048"/>
+          </a:xfrm>
+          <a:prstGeom prst="roundRect">
+            <a:avLst>
+              <a:gd name="adj" fmla="val 19048"/>
+            </a:avLst>
+          </a:prstGeom>
+          <a:solidFill>
+            <a:srgbClr val="262633"/>
+          </a:solidFill>
+          <a:ln w="12700">
+            <a:solidFill>
+              <a:srgbClr val="9A9AB0"/>
+            </a:solidFill>
+            <a:prstDash val="solid"/>
+          </a:ln>
+        </p:spPr>
+      </p:sp>
+      <p:sp>
+        <p:nvSpPr>
+          <p:cNvPr id="15" name="TimerResetBtn"/>
+          <p:cNvSpPr/>
+          <p:nvPr/>
+        </p:nvSpPr>
+        <p:spPr>
+          <a:xfrm>
+            <a:off x="7712964" y="896112"/>
+            <a:ext cx="685800" cy="384048"/>
+          </a:xfrm>
+          <a:prstGeom prst="rect">
+            <a:avLst/>
+          </a:prstGeom>
+          <a:noFill/>
+          <a:ln/>
+        </p:spPr>
+        <p:txBody>
+          <a:bodyPr wrap="square" lIns="0" tIns="0" rIns="0" bIns="0" rtlCol="0" anchor="ctr"/>
+          <a:lstStyle/>
+          <a:p>
+            <a:pPr algn="ctr" indent="0" marL="0">
+              <a:buNone/>
+            </a:pPr>
+            <a:r>
+              <a:rPr lang="en-US" sz="1100" b="1" dirty="0">
+                <a:solidFill>
+                  <a:srgbClr val="9A9AB0"/>
+                </a:solidFill>
+                <a:latin typeface="Calibri" pitchFamily="34" charset="0"/>
+                <a:ea typeface="Calibri" pitchFamily="34" charset="-122"/>
+                <a:cs typeface="Calibri" pitchFamily="34" charset="-120"/>
+              </a:rPr>
+              <a:t>RESET</a:t>
+            </a:r>
+            <a:endParaRPr lang="en-US" sz="1100" dirty="0"/>
+          </a:p>
+        </p:txBody>
+      </p:sp>
+      <p:sp>
+        <p:nvSpPr>
+          <p:cNvPr id="16" name="Shape 14"/>
           <p:cNvSpPr/>
           <p:nvPr/>
         </p:nvSpPr>
@@ -21462,7 +22360,7 @@
       </p:sp>
       <p:sp>
         <p:nvSpPr>
-          <p:cNvPr id="15" name="Text 13"/>
+          <p:cNvPr id="17" name="Text 15"/>
           <p:cNvSpPr/>
           <p:nvPr/>
         </p:nvSpPr>
@@ -21506,7 +22404,7 @@
       </p:sp>
       <p:sp>
         <p:nvSpPr>
-          <p:cNvPr id="16" name="Text 14"/>
+          <p:cNvPr id="18" name="Text 16"/>
           <p:cNvSpPr/>
           <p:nvPr/>
         </p:nvSpPr>
@@ -21545,7 +22443,7 @@
       </p:sp>
       <p:sp>
         <p:nvSpPr>
-          <p:cNvPr id="17" name="Text 15"/>
+          <p:cNvPr id="19" name="Text 17"/>
           <p:cNvSpPr/>
           <p:nvPr/>
         </p:nvSpPr>
@@ -24525,7 +25423,7 @@
         </p:nvSpPr>
         <p:spPr>
           <a:xfrm>
-            <a:off x="4178808" y="896112"/>
+            <a:off x="3790188" y="896112"/>
             <a:ext cx="310896" cy="384048"/>
           </a:xfrm>
           <a:prstGeom prst="rect">
@@ -24564,7 +25462,7 @@
         </p:nvSpPr>
         <p:spPr>
           <a:xfrm>
-            <a:off x="4581144" y="896112"/>
+            <a:off x="4192524" y="896112"/>
             <a:ext cx="868680" cy="384048"/>
           </a:xfrm>
           <a:prstGeom prst="roundRect">
@@ -24591,7 +25489,7 @@
         </p:nvSpPr>
         <p:spPr>
           <a:xfrm>
-            <a:off x="4581144" y="896112"/>
+            <a:off x="4192524" y="896112"/>
             <a:ext cx="868680" cy="384048"/>
           </a:xfrm>
           <a:prstGeom prst="rect">
@@ -24630,7 +25528,7 @@
         </p:nvSpPr>
         <p:spPr>
           <a:xfrm>
-            <a:off x="5541264" y="896112"/>
+            <a:off x="5152644" y="896112"/>
             <a:ext cx="1143000" cy="384048"/>
           </a:xfrm>
           <a:prstGeom prst="roundRect">
@@ -24657,7 +25555,7 @@
         </p:nvSpPr>
         <p:spPr>
           <a:xfrm>
-            <a:off x="5541264" y="896112"/>
+            <a:off x="5152644" y="896112"/>
             <a:ext cx="1143000" cy="384048"/>
           </a:xfrm>
           <a:prstGeom prst="rect">
@@ -24696,7 +25594,7 @@
         </p:nvSpPr>
         <p:spPr>
           <a:xfrm>
-            <a:off x="6775704" y="896112"/>
+            <a:off x="6387084" y="896112"/>
             <a:ext cx="1234440" cy="384048"/>
           </a:xfrm>
           <a:prstGeom prst="roundRect">
@@ -24723,7 +25621,7 @@
         </p:nvSpPr>
         <p:spPr>
           <a:xfrm>
-            <a:off x="6775704" y="896112"/>
+            <a:off x="6387084" y="896112"/>
             <a:ext cx="1234440" cy="384048"/>
           </a:xfrm>
           <a:prstGeom prst="rect">
@@ -24757,6 +25655,72 @@
       <p:sp>
         <p:nvSpPr>
           <p:cNvPr id="14" name="Shape 12"/>
+          <p:cNvSpPr/>
+          <p:nvPr/>
+        </p:nvSpPr>
+        <p:spPr>
+          <a:xfrm>
+            <a:off x="7712964" y="896112"/>
+            <a:ext cx="685800" cy="384048"/>
+          </a:xfrm>
+          <a:prstGeom prst="roundRect">
+            <a:avLst>
+              <a:gd name="adj" fmla="val 19048"/>
+            </a:avLst>
+          </a:prstGeom>
+          <a:solidFill>
+            <a:srgbClr val="262633"/>
+          </a:solidFill>
+          <a:ln w="12700">
+            <a:solidFill>
+              <a:srgbClr val="9A9AB0"/>
+            </a:solidFill>
+            <a:prstDash val="solid"/>
+          </a:ln>
+        </p:spPr>
+      </p:sp>
+      <p:sp>
+        <p:nvSpPr>
+          <p:cNvPr id="15" name="TimerResetBtn"/>
+          <p:cNvSpPr/>
+          <p:nvPr/>
+        </p:nvSpPr>
+        <p:spPr>
+          <a:xfrm>
+            <a:off x="7712964" y="896112"/>
+            <a:ext cx="685800" cy="384048"/>
+          </a:xfrm>
+          <a:prstGeom prst="rect">
+            <a:avLst/>
+          </a:prstGeom>
+          <a:noFill/>
+          <a:ln/>
+        </p:spPr>
+        <p:txBody>
+          <a:bodyPr wrap="square" lIns="0" tIns="0" rIns="0" bIns="0" rtlCol="0" anchor="ctr"/>
+          <a:lstStyle/>
+          <a:p>
+            <a:pPr algn="ctr" indent="0" marL="0">
+              <a:buNone/>
+            </a:pPr>
+            <a:r>
+              <a:rPr lang="en-US" sz="1100" b="1" dirty="0">
+                <a:solidFill>
+                  <a:srgbClr val="9A9AB0"/>
+                </a:solidFill>
+                <a:latin typeface="Calibri" pitchFamily="34" charset="0"/>
+                <a:ea typeface="Calibri" pitchFamily="34" charset="-122"/>
+                <a:cs typeface="Calibri" pitchFamily="34" charset="-120"/>
+              </a:rPr>
+              <a:t>RESET</a:t>
+            </a:r>
+            <a:endParaRPr lang="en-US" sz="1100" dirty="0"/>
+          </a:p>
+        </p:txBody>
+      </p:sp>
+      <p:sp>
+        <p:nvSpPr>
+          <p:cNvPr id="16" name="Shape 14"/>
           <p:cNvSpPr/>
           <p:nvPr/>
         </p:nvSpPr>
@@ -24783,7 +25747,7 @@
       </p:sp>
       <p:sp>
         <p:nvSpPr>
-          <p:cNvPr id="15" name="Text 13"/>
+          <p:cNvPr id="17" name="Text 15"/>
           <p:cNvSpPr/>
           <p:nvPr/>
         </p:nvSpPr>
@@ -24827,7 +25791,7 @@
       </p:sp>
       <p:sp>
         <p:nvSpPr>
-          <p:cNvPr id="16" name="Text 14"/>
+          <p:cNvPr id="18" name="Text 16"/>
           <p:cNvSpPr/>
           <p:nvPr/>
         </p:nvSpPr>
@@ -24866,7 +25830,7 @@
       </p:sp>
       <p:sp>
         <p:nvSpPr>
-          <p:cNvPr id="17" name="Text 15"/>
+          <p:cNvPr id="19" name="Text 17"/>
           <p:cNvSpPr/>
           <p:nvPr/>
         </p:nvSpPr>
@@ -25407,7 +26371,7 @@
         </p:nvSpPr>
         <p:spPr>
           <a:xfrm>
-            <a:off x="4178808" y="896112"/>
+            <a:off x="3790188" y="896112"/>
             <a:ext cx="310896" cy="384048"/>
           </a:xfrm>
           <a:prstGeom prst="rect">
@@ -25446,7 +26410,7 @@
         </p:nvSpPr>
         <p:spPr>
           <a:xfrm>
-            <a:off x="4581144" y="896112"/>
+            <a:off x="4192524" y="896112"/>
             <a:ext cx="868680" cy="384048"/>
           </a:xfrm>
           <a:prstGeom prst="roundRect">
@@ -25473,7 +26437,7 @@
         </p:nvSpPr>
         <p:spPr>
           <a:xfrm>
-            <a:off x="4581144" y="896112"/>
+            <a:off x="4192524" y="896112"/>
             <a:ext cx="868680" cy="384048"/>
           </a:xfrm>
           <a:prstGeom prst="rect">
@@ -25512,7 +26476,7 @@
         </p:nvSpPr>
         <p:spPr>
           <a:xfrm>
-            <a:off x="5541264" y="896112"/>
+            <a:off x="5152644" y="896112"/>
             <a:ext cx="1143000" cy="384048"/>
           </a:xfrm>
           <a:prstGeom prst="roundRect">
@@ -25539,7 +26503,7 @@
         </p:nvSpPr>
         <p:spPr>
           <a:xfrm>
-            <a:off x="5541264" y="896112"/>
+            <a:off x="5152644" y="896112"/>
             <a:ext cx="1143000" cy="384048"/>
           </a:xfrm>
           <a:prstGeom prst="rect">
@@ -25578,7 +26542,7 @@
         </p:nvSpPr>
         <p:spPr>
           <a:xfrm>
-            <a:off x="6775704" y="896112"/>
+            <a:off x="6387084" y="896112"/>
             <a:ext cx="1234440" cy="384048"/>
           </a:xfrm>
           <a:prstGeom prst="roundRect">
@@ -25605,7 +26569,7 @@
         </p:nvSpPr>
         <p:spPr>
           <a:xfrm>
-            <a:off x="6775704" y="896112"/>
+            <a:off x="6387084" y="896112"/>
             <a:ext cx="1234440" cy="384048"/>
           </a:xfrm>
           <a:prstGeom prst="rect">
@@ -25639,6 +26603,72 @@
       <p:sp>
         <p:nvSpPr>
           <p:cNvPr id="14" name="Shape 12"/>
+          <p:cNvSpPr/>
+          <p:nvPr/>
+        </p:nvSpPr>
+        <p:spPr>
+          <a:xfrm>
+            <a:off x="7712964" y="896112"/>
+            <a:ext cx="685800" cy="384048"/>
+          </a:xfrm>
+          <a:prstGeom prst="roundRect">
+            <a:avLst>
+              <a:gd name="adj" fmla="val 19048"/>
+            </a:avLst>
+          </a:prstGeom>
+          <a:solidFill>
+            <a:srgbClr val="262633"/>
+          </a:solidFill>
+          <a:ln w="12700">
+            <a:solidFill>
+              <a:srgbClr val="9A9AB0"/>
+            </a:solidFill>
+            <a:prstDash val="solid"/>
+          </a:ln>
+        </p:spPr>
+      </p:sp>
+      <p:sp>
+        <p:nvSpPr>
+          <p:cNvPr id="15" name="TimerResetBtn"/>
+          <p:cNvSpPr/>
+          <p:nvPr/>
+        </p:nvSpPr>
+        <p:spPr>
+          <a:xfrm>
+            <a:off x="7712964" y="896112"/>
+            <a:ext cx="685800" cy="384048"/>
+          </a:xfrm>
+          <a:prstGeom prst="rect">
+            <a:avLst/>
+          </a:prstGeom>
+          <a:noFill/>
+          <a:ln/>
+        </p:spPr>
+        <p:txBody>
+          <a:bodyPr wrap="square" lIns="0" tIns="0" rIns="0" bIns="0" rtlCol="0" anchor="ctr"/>
+          <a:lstStyle/>
+          <a:p>
+            <a:pPr algn="ctr" indent="0" marL="0">
+              <a:buNone/>
+            </a:pPr>
+            <a:r>
+              <a:rPr lang="en-US" sz="1100" b="1" dirty="0">
+                <a:solidFill>
+                  <a:srgbClr val="9A9AB0"/>
+                </a:solidFill>
+                <a:latin typeface="Calibri" pitchFamily="34" charset="0"/>
+                <a:ea typeface="Calibri" pitchFamily="34" charset="-122"/>
+                <a:cs typeface="Calibri" pitchFamily="34" charset="-120"/>
+              </a:rPr>
+              <a:t>RESET</a:t>
+            </a:r>
+            <a:endParaRPr lang="en-US" sz="1100" dirty="0"/>
+          </a:p>
+        </p:txBody>
+      </p:sp>
+      <p:sp>
+        <p:nvSpPr>
+          <p:cNvPr id="16" name="Shape 14"/>
           <p:cNvSpPr/>
           <p:nvPr/>
         </p:nvSpPr>
@@ -25665,7 +26695,7 @@
       </p:sp>
       <p:sp>
         <p:nvSpPr>
-          <p:cNvPr id="15" name="Text 13"/>
+          <p:cNvPr id="17" name="Text 15"/>
           <p:cNvSpPr/>
           <p:nvPr/>
         </p:nvSpPr>
@@ -25709,7 +26739,7 @@
       </p:sp>
       <p:sp>
         <p:nvSpPr>
-          <p:cNvPr id="16" name="Text 14"/>
+          <p:cNvPr id="18" name="Text 16"/>
           <p:cNvSpPr/>
           <p:nvPr/>
         </p:nvSpPr>
@@ -25748,7 +26778,7 @@
       </p:sp>
       <p:sp>
         <p:nvSpPr>
-          <p:cNvPr id="17" name="Text 15"/>
+          <p:cNvPr id="19" name="Text 17"/>
           <p:cNvSpPr/>
           <p:nvPr/>
         </p:nvSpPr>
@@ -26360,7 +27390,7 @@
         </p:nvSpPr>
         <p:spPr>
           <a:xfrm>
-            <a:off x="4178808" y="896112"/>
+            <a:off x="3790188" y="896112"/>
             <a:ext cx="310896" cy="384048"/>
           </a:xfrm>
           <a:prstGeom prst="rect">
@@ -26399,7 +27429,7 @@
         </p:nvSpPr>
         <p:spPr>
           <a:xfrm>
-            <a:off x="4581144" y="896112"/>
+            <a:off x="4192524" y="896112"/>
             <a:ext cx="868680" cy="384048"/>
           </a:xfrm>
           <a:prstGeom prst="roundRect">
@@ -26426,7 +27456,7 @@
         </p:nvSpPr>
         <p:spPr>
           <a:xfrm>
-            <a:off x="4581144" y="896112"/>
+            <a:off x="4192524" y="896112"/>
             <a:ext cx="868680" cy="384048"/>
           </a:xfrm>
           <a:prstGeom prst="rect">
@@ -26465,7 +27495,7 @@
         </p:nvSpPr>
         <p:spPr>
           <a:xfrm>
-            <a:off x="5541264" y="896112"/>
+            <a:off x="5152644" y="896112"/>
             <a:ext cx="1143000" cy="384048"/>
           </a:xfrm>
           <a:prstGeom prst="roundRect">
@@ -26492,7 +27522,7 @@
         </p:nvSpPr>
         <p:spPr>
           <a:xfrm>
-            <a:off x="5541264" y="896112"/>
+            <a:off x="5152644" y="896112"/>
             <a:ext cx="1143000" cy="384048"/>
           </a:xfrm>
           <a:prstGeom prst="rect">
@@ -26531,7 +27561,7 @@
         </p:nvSpPr>
         <p:spPr>
           <a:xfrm>
-            <a:off x="6775704" y="896112"/>
+            <a:off x="6387084" y="896112"/>
             <a:ext cx="1234440" cy="384048"/>
           </a:xfrm>
           <a:prstGeom prst="roundRect">
@@ -26558,7 +27588,7 @@
         </p:nvSpPr>
         <p:spPr>
           <a:xfrm>
-            <a:off x="6775704" y="896112"/>
+            <a:off x="6387084" y="896112"/>
             <a:ext cx="1234440" cy="384048"/>
           </a:xfrm>
           <a:prstGeom prst="rect">
@@ -26592,6 +27622,72 @@
       <p:sp>
         <p:nvSpPr>
           <p:cNvPr id="14" name="Shape 12"/>
+          <p:cNvSpPr/>
+          <p:nvPr/>
+        </p:nvSpPr>
+        <p:spPr>
+          <a:xfrm>
+            <a:off x="7712964" y="896112"/>
+            <a:ext cx="685800" cy="384048"/>
+          </a:xfrm>
+          <a:prstGeom prst="roundRect">
+            <a:avLst>
+              <a:gd name="adj" fmla="val 19048"/>
+            </a:avLst>
+          </a:prstGeom>
+          <a:solidFill>
+            <a:srgbClr val="262633"/>
+          </a:solidFill>
+          <a:ln w="12700">
+            <a:solidFill>
+              <a:srgbClr val="9A9AB0"/>
+            </a:solidFill>
+            <a:prstDash val="solid"/>
+          </a:ln>
+        </p:spPr>
+      </p:sp>
+      <p:sp>
+        <p:nvSpPr>
+          <p:cNvPr id="15" name="TimerResetBtn"/>
+          <p:cNvSpPr/>
+          <p:nvPr/>
+        </p:nvSpPr>
+        <p:spPr>
+          <a:xfrm>
+            <a:off x="7712964" y="896112"/>
+            <a:ext cx="685800" cy="384048"/>
+          </a:xfrm>
+          <a:prstGeom prst="rect">
+            <a:avLst/>
+          </a:prstGeom>
+          <a:noFill/>
+          <a:ln/>
+        </p:spPr>
+        <p:txBody>
+          <a:bodyPr wrap="square" lIns="0" tIns="0" rIns="0" bIns="0" rtlCol="0" anchor="ctr"/>
+          <a:lstStyle/>
+          <a:p>
+            <a:pPr algn="ctr" indent="0" marL="0">
+              <a:buNone/>
+            </a:pPr>
+            <a:r>
+              <a:rPr lang="en-US" sz="1100" b="1" dirty="0">
+                <a:solidFill>
+                  <a:srgbClr val="9A9AB0"/>
+                </a:solidFill>
+                <a:latin typeface="Calibri" pitchFamily="34" charset="0"/>
+                <a:ea typeface="Calibri" pitchFamily="34" charset="-122"/>
+                <a:cs typeface="Calibri" pitchFamily="34" charset="-120"/>
+              </a:rPr>
+              <a:t>RESET</a:t>
+            </a:r>
+            <a:endParaRPr lang="en-US" sz="1100" dirty="0"/>
+          </a:p>
+        </p:txBody>
+      </p:sp>
+      <p:sp>
+        <p:nvSpPr>
+          <p:cNvPr id="16" name="Shape 14"/>
           <p:cNvSpPr/>
           <p:nvPr/>
         </p:nvSpPr>
@@ -26618,7 +27714,7 @@
       </p:sp>
       <p:sp>
         <p:nvSpPr>
-          <p:cNvPr id="15" name="Text 13"/>
+          <p:cNvPr id="17" name="Text 15"/>
           <p:cNvSpPr/>
           <p:nvPr/>
         </p:nvSpPr>
@@ -26662,7 +27758,7 @@
       </p:sp>
       <p:sp>
         <p:nvSpPr>
-          <p:cNvPr id="16" name="Text 14"/>
+          <p:cNvPr id="18" name="Text 16"/>
           <p:cNvSpPr/>
           <p:nvPr/>
         </p:nvSpPr>
@@ -26701,7 +27797,7 @@
       </p:sp>
       <p:sp>
         <p:nvSpPr>
-          <p:cNvPr id="17" name="Text 15"/>
+          <p:cNvPr id="19" name="Text 17"/>
           <p:cNvSpPr/>
           <p:nvPr/>
         </p:nvSpPr>
@@ -27313,7 +28409,7 @@
         </p:nvSpPr>
         <p:spPr>
           <a:xfrm>
-            <a:off x="4178808" y="896112"/>
+            <a:off x="3790188" y="896112"/>
             <a:ext cx="310896" cy="384048"/>
           </a:xfrm>
           <a:prstGeom prst="rect">
@@ -27352,7 +28448,7 @@
         </p:nvSpPr>
         <p:spPr>
           <a:xfrm>
-            <a:off x="4581144" y="896112"/>
+            <a:off x="4192524" y="896112"/>
             <a:ext cx="868680" cy="384048"/>
           </a:xfrm>
           <a:prstGeom prst="roundRect">
@@ -27379,7 +28475,7 @@
         </p:nvSpPr>
         <p:spPr>
           <a:xfrm>
-            <a:off x="4581144" y="896112"/>
+            <a:off x="4192524" y="896112"/>
             <a:ext cx="868680" cy="384048"/>
           </a:xfrm>
           <a:prstGeom prst="rect">
@@ -27418,7 +28514,7 @@
         </p:nvSpPr>
         <p:spPr>
           <a:xfrm>
-            <a:off x="5541264" y="896112"/>
+            <a:off x="5152644" y="896112"/>
             <a:ext cx="1143000" cy="384048"/>
           </a:xfrm>
           <a:prstGeom prst="roundRect">
@@ -27445,7 +28541,7 @@
         </p:nvSpPr>
         <p:spPr>
           <a:xfrm>
-            <a:off x="5541264" y="896112"/>
+            <a:off x="5152644" y="896112"/>
             <a:ext cx="1143000" cy="384048"/>
           </a:xfrm>
           <a:prstGeom prst="rect">
@@ -27484,7 +28580,7 @@
         </p:nvSpPr>
         <p:spPr>
           <a:xfrm>
-            <a:off x="6775704" y="896112"/>
+            <a:off x="6387084" y="896112"/>
             <a:ext cx="1234440" cy="384048"/>
           </a:xfrm>
           <a:prstGeom prst="roundRect">
@@ -27511,7 +28607,7 @@
         </p:nvSpPr>
         <p:spPr>
           <a:xfrm>
-            <a:off x="6775704" y="896112"/>
+            <a:off x="6387084" y="896112"/>
             <a:ext cx="1234440" cy="384048"/>
           </a:xfrm>
           <a:prstGeom prst="rect">
@@ -27545,6 +28641,72 @@
       <p:sp>
         <p:nvSpPr>
           <p:cNvPr id="14" name="Shape 12"/>
+          <p:cNvSpPr/>
+          <p:nvPr/>
+        </p:nvSpPr>
+        <p:spPr>
+          <a:xfrm>
+            <a:off x="7712964" y="896112"/>
+            <a:ext cx="685800" cy="384048"/>
+          </a:xfrm>
+          <a:prstGeom prst="roundRect">
+            <a:avLst>
+              <a:gd name="adj" fmla="val 19048"/>
+            </a:avLst>
+          </a:prstGeom>
+          <a:solidFill>
+            <a:srgbClr val="262633"/>
+          </a:solidFill>
+          <a:ln w="12700">
+            <a:solidFill>
+              <a:srgbClr val="9A9AB0"/>
+            </a:solidFill>
+            <a:prstDash val="solid"/>
+          </a:ln>
+        </p:spPr>
+      </p:sp>
+      <p:sp>
+        <p:nvSpPr>
+          <p:cNvPr id="15" name="TimerResetBtn"/>
+          <p:cNvSpPr/>
+          <p:nvPr/>
+        </p:nvSpPr>
+        <p:spPr>
+          <a:xfrm>
+            <a:off x="7712964" y="896112"/>
+            <a:ext cx="685800" cy="384048"/>
+          </a:xfrm>
+          <a:prstGeom prst="rect">
+            <a:avLst/>
+          </a:prstGeom>
+          <a:noFill/>
+          <a:ln/>
+        </p:spPr>
+        <p:txBody>
+          <a:bodyPr wrap="square" lIns="0" tIns="0" rIns="0" bIns="0" rtlCol="0" anchor="ctr"/>
+          <a:lstStyle/>
+          <a:p>
+            <a:pPr algn="ctr" indent="0" marL="0">
+              <a:buNone/>
+            </a:pPr>
+            <a:r>
+              <a:rPr lang="en-US" sz="1100" b="1" dirty="0">
+                <a:solidFill>
+                  <a:srgbClr val="9A9AB0"/>
+                </a:solidFill>
+                <a:latin typeface="Calibri" pitchFamily="34" charset="0"/>
+                <a:ea typeface="Calibri" pitchFamily="34" charset="-122"/>
+                <a:cs typeface="Calibri" pitchFamily="34" charset="-120"/>
+              </a:rPr>
+              <a:t>RESET</a:t>
+            </a:r>
+            <a:endParaRPr lang="en-US" sz="1100" dirty="0"/>
+          </a:p>
+        </p:txBody>
+      </p:sp>
+      <p:sp>
+        <p:nvSpPr>
+          <p:cNvPr id="16" name="Shape 14"/>
           <p:cNvSpPr/>
           <p:nvPr/>
         </p:nvSpPr>
@@ -27571,7 +28733,7 @@
       </p:sp>
       <p:sp>
         <p:nvSpPr>
-          <p:cNvPr id="15" name="Text 13"/>
+          <p:cNvPr id="17" name="Text 15"/>
           <p:cNvSpPr/>
           <p:nvPr/>
         </p:nvSpPr>
@@ -27615,7 +28777,7 @@
       </p:sp>
       <p:sp>
         <p:nvSpPr>
-          <p:cNvPr id="16" name="Text 14"/>
+          <p:cNvPr id="18" name="Text 16"/>
           <p:cNvSpPr/>
           <p:nvPr/>
         </p:nvSpPr>
@@ -27654,7 +28816,7 @@
       </p:sp>
       <p:sp>
         <p:nvSpPr>
-          <p:cNvPr id="17" name="Text 15"/>
+          <p:cNvPr id="19" name="Text 17"/>
           <p:cNvSpPr/>
           <p:nvPr/>
         </p:nvSpPr>
@@ -28266,7 +29428,7 @@
         </p:nvSpPr>
         <p:spPr>
           <a:xfrm>
-            <a:off x="4178808" y="896112"/>
+            <a:off x="3790188" y="896112"/>
             <a:ext cx="310896" cy="384048"/>
           </a:xfrm>
           <a:prstGeom prst="rect">
@@ -28305,7 +29467,7 @@
         </p:nvSpPr>
         <p:spPr>
           <a:xfrm>
-            <a:off x="4581144" y="896112"/>
+            <a:off x="4192524" y="896112"/>
             <a:ext cx="868680" cy="384048"/>
           </a:xfrm>
           <a:prstGeom prst="roundRect">
@@ -28332,7 +29494,7 @@
         </p:nvSpPr>
         <p:spPr>
           <a:xfrm>
-            <a:off x="4581144" y="896112"/>
+            <a:off x="4192524" y="896112"/>
             <a:ext cx="868680" cy="384048"/>
           </a:xfrm>
           <a:prstGeom prst="rect">
@@ -28371,7 +29533,7 @@
         </p:nvSpPr>
         <p:spPr>
           <a:xfrm>
-            <a:off x="5541264" y="896112"/>
+            <a:off x="5152644" y="896112"/>
             <a:ext cx="1143000" cy="384048"/>
           </a:xfrm>
           <a:prstGeom prst="roundRect">
@@ -28398,7 +29560,7 @@
         </p:nvSpPr>
         <p:spPr>
           <a:xfrm>
-            <a:off x="5541264" y="896112"/>
+            <a:off x="5152644" y="896112"/>
             <a:ext cx="1143000" cy="384048"/>
           </a:xfrm>
           <a:prstGeom prst="rect">
@@ -28437,7 +29599,7 @@
         </p:nvSpPr>
         <p:spPr>
           <a:xfrm>
-            <a:off x="6775704" y="896112"/>
+            <a:off x="6387084" y="896112"/>
             <a:ext cx="1234440" cy="384048"/>
           </a:xfrm>
           <a:prstGeom prst="roundRect">
@@ -28464,7 +29626,7 @@
         </p:nvSpPr>
         <p:spPr>
           <a:xfrm>
-            <a:off x="6775704" y="896112"/>
+            <a:off x="6387084" y="896112"/>
             <a:ext cx="1234440" cy="384048"/>
           </a:xfrm>
           <a:prstGeom prst="rect">
@@ -28498,6 +29660,72 @@
       <p:sp>
         <p:nvSpPr>
           <p:cNvPr id="14" name="Shape 12"/>
+          <p:cNvSpPr/>
+          <p:nvPr/>
+        </p:nvSpPr>
+        <p:spPr>
+          <a:xfrm>
+            <a:off x="7712964" y="896112"/>
+            <a:ext cx="685800" cy="384048"/>
+          </a:xfrm>
+          <a:prstGeom prst="roundRect">
+            <a:avLst>
+              <a:gd name="adj" fmla="val 19048"/>
+            </a:avLst>
+          </a:prstGeom>
+          <a:solidFill>
+            <a:srgbClr val="262633"/>
+          </a:solidFill>
+          <a:ln w="12700">
+            <a:solidFill>
+              <a:srgbClr val="9A9AB0"/>
+            </a:solidFill>
+            <a:prstDash val="solid"/>
+          </a:ln>
+        </p:spPr>
+      </p:sp>
+      <p:sp>
+        <p:nvSpPr>
+          <p:cNvPr id="15" name="TimerResetBtn"/>
+          <p:cNvSpPr/>
+          <p:nvPr/>
+        </p:nvSpPr>
+        <p:spPr>
+          <a:xfrm>
+            <a:off x="7712964" y="896112"/>
+            <a:ext cx="685800" cy="384048"/>
+          </a:xfrm>
+          <a:prstGeom prst="rect">
+            <a:avLst/>
+          </a:prstGeom>
+          <a:noFill/>
+          <a:ln/>
+        </p:spPr>
+        <p:txBody>
+          <a:bodyPr wrap="square" lIns="0" tIns="0" rIns="0" bIns="0" rtlCol="0" anchor="ctr"/>
+          <a:lstStyle/>
+          <a:p>
+            <a:pPr algn="ctr" indent="0" marL="0">
+              <a:buNone/>
+            </a:pPr>
+            <a:r>
+              <a:rPr lang="en-US" sz="1100" b="1" dirty="0">
+                <a:solidFill>
+                  <a:srgbClr val="9A9AB0"/>
+                </a:solidFill>
+                <a:latin typeface="Calibri" pitchFamily="34" charset="0"/>
+                <a:ea typeface="Calibri" pitchFamily="34" charset="-122"/>
+                <a:cs typeface="Calibri" pitchFamily="34" charset="-120"/>
+              </a:rPr>
+              <a:t>RESET</a:t>
+            </a:r>
+            <a:endParaRPr lang="en-US" sz="1100" dirty="0"/>
+          </a:p>
+        </p:txBody>
+      </p:sp>
+      <p:sp>
+        <p:nvSpPr>
+          <p:cNvPr id="16" name="Shape 14"/>
           <p:cNvSpPr/>
           <p:nvPr/>
         </p:nvSpPr>
@@ -28524,7 +29752,7 @@
       </p:sp>
       <p:sp>
         <p:nvSpPr>
-          <p:cNvPr id="15" name="Text 13"/>
+          <p:cNvPr id="17" name="Text 15"/>
           <p:cNvSpPr/>
           <p:nvPr/>
         </p:nvSpPr>
@@ -28568,7 +29796,7 @@
       </p:sp>
       <p:sp>
         <p:nvSpPr>
-          <p:cNvPr id="16" name="Text 14"/>
+          <p:cNvPr id="18" name="Text 16"/>
           <p:cNvSpPr/>
           <p:nvPr/>
         </p:nvSpPr>
@@ -28607,7 +29835,7 @@
       </p:sp>
       <p:sp>
         <p:nvSpPr>
-          <p:cNvPr id="17" name="Text 15"/>
+          <p:cNvPr id="19" name="Text 17"/>
           <p:cNvSpPr/>
           <p:nvPr/>
         </p:nvSpPr>
@@ -33428,7 +34656,7 @@
         </p:nvSpPr>
         <p:spPr>
           <a:xfrm>
-            <a:off x="4178808" y="896112"/>
+            <a:off x="3790188" y="896112"/>
             <a:ext cx="310896" cy="384048"/>
           </a:xfrm>
           <a:prstGeom prst="rect">
@@ -33467,7 +34695,7 @@
         </p:nvSpPr>
         <p:spPr>
           <a:xfrm>
-            <a:off x="4581144" y="896112"/>
+            <a:off x="4192524" y="896112"/>
             <a:ext cx="868680" cy="384048"/>
           </a:xfrm>
           <a:prstGeom prst="roundRect">
@@ -33494,7 +34722,7 @@
         </p:nvSpPr>
         <p:spPr>
           <a:xfrm>
-            <a:off x="4581144" y="896112"/>
+            <a:off x="4192524" y="896112"/>
             <a:ext cx="868680" cy="384048"/>
           </a:xfrm>
           <a:prstGeom prst="rect">
@@ -33533,7 +34761,7 @@
         </p:nvSpPr>
         <p:spPr>
           <a:xfrm>
-            <a:off x="5541264" y="896112"/>
+            <a:off x="5152644" y="896112"/>
             <a:ext cx="1143000" cy="384048"/>
           </a:xfrm>
           <a:prstGeom prst="roundRect">
@@ -33560,7 +34788,7 @@
         </p:nvSpPr>
         <p:spPr>
           <a:xfrm>
-            <a:off x="5541264" y="896112"/>
+            <a:off x="5152644" y="896112"/>
             <a:ext cx="1143000" cy="384048"/>
           </a:xfrm>
           <a:prstGeom prst="rect">
@@ -33599,7 +34827,7 @@
         </p:nvSpPr>
         <p:spPr>
           <a:xfrm>
-            <a:off x="6775704" y="896112"/>
+            <a:off x="6387084" y="896112"/>
             <a:ext cx="1234440" cy="384048"/>
           </a:xfrm>
           <a:prstGeom prst="roundRect">
@@ -33626,7 +34854,7 @@
         </p:nvSpPr>
         <p:spPr>
           <a:xfrm>
-            <a:off x="6775704" y="896112"/>
+            <a:off x="6387084" y="896112"/>
             <a:ext cx="1234440" cy="384048"/>
           </a:xfrm>
           <a:prstGeom prst="rect">
@@ -33660,6 +34888,72 @@
       <p:sp>
         <p:nvSpPr>
           <p:cNvPr id="14" name="Shape 12"/>
+          <p:cNvSpPr/>
+          <p:nvPr/>
+        </p:nvSpPr>
+        <p:spPr>
+          <a:xfrm>
+            <a:off x="7712964" y="896112"/>
+            <a:ext cx="685800" cy="384048"/>
+          </a:xfrm>
+          <a:prstGeom prst="roundRect">
+            <a:avLst>
+              <a:gd name="adj" fmla="val 19048"/>
+            </a:avLst>
+          </a:prstGeom>
+          <a:solidFill>
+            <a:srgbClr val="262633"/>
+          </a:solidFill>
+          <a:ln w="12700">
+            <a:solidFill>
+              <a:srgbClr val="9A9AB0"/>
+            </a:solidFill>
+            <a:prstDash val="solid"/>
+          </a:ln>
+        </p:spPr>
+      </p:sp>
+      <p:sp>
+        <p:nvSpPr>
+          <p:cNvPr id="15" name="TimerResetBtn"/>
+          <p:cNvSpPr/>
+          <p:nvPr/>
+        </p:nvSpPr>
+        <p:spPr>
+          <a:xfrm>
+            <a:off x="7712964" y="896112"/>
+            <a:ext cx="685800" cy="384048"/>
+          </a:xfrm>
+          <a:prstGeom prst="rect">
+            <a:avLst/>
+          </a:prstGeom>
+          <a:noFill/>
+          <a:ln/>
+        </p:spPr>
+        <p:txBody>
+          <a:bodyPr wrap="square" lIns="0" tIns="0" rIns="0" bIns="0" rtlCol="0" anchor="ctr"/>
+          <a:lstStyle/>
+          <a:p>
+            <a:pPr algn="ctr" indent="0" marL="0">
+              <a:buNone/>
+            </a:pPr>
+            <a:r>
+              <a:rPr lang="en-US" sz="1100" b="1" dirty="0">
+                <a:solidFill>
+                  <a:srgbClr val="9A9AB0"/>
+                </a:solidFill>
+                <a:latin typeface="Calibri" pitchFamily="34" charset="0"/>
+                <a:ea typeface="Calibri" pitchFamily="34" charset="-122"/>
+                <a:cs typeface="Calibri" pitchFamily="34" charset="-120"/>
+              </a:rPr>
+              <a:t>RESET</a:t>
+            </a:r>
+            <a:endParaRPr lang="en-US" sz="1100" dirty="0"/>
+          </a:p>
+        </p:txBody>
+      </p:sp>
+      <p:sp>
+        <p:nvSpPr>
+          <p:cNvPr id="16" name="Shape 14"/>
           <p:cNvSpPr/>
           <p:nvPr/>
         </p:nvSpPr>
@@ -33686,7 +34980,7 @@
       </p:sp>
       <p:sp>
         <p:nvSpPr>
-          <p:cNvPr id="15" name="Text 13"/>
+          <p:cNvPr id="17" name="Text 15"/>
           <p:cNvSpPr/>
           <p:nvPr/>
         </p:nvSpPr>
@@ -33730,7 +35024,7 @@
       </p:sp>
       <p:sp>
         <p:nvSpPr>
-          <p:cNvPr id="16" name="Text 14"/>
+          <p:cNvPr id="18" name="Text 16"/>
           <p:cNvSpPr/>
           <p:nvPr/>
         </p:nvSpPr>
@@ -33769,7 +35063,7 @@
       </p:sp>
       <p:sp>
         <p:nvSpPr>
-          <p:cNvPr id="17" name="Text 15"/>
+          <p:cNvPr id="19" name="Text 17"/>
           <p:cNvSpPr/>
           <p:nvPr/>
         </p:nvSpPr>
@@ -34381,7 +35675,7 @@
         </p:nvSpPr>
         <p:spPr>
           <a:xfrm>
-            <a:off x="4178808" y="896112"/>
+            <a:off x="3790188" y="896112"/>
             <a:ext cx="310896" cy="384048"/>
           </a:xfrm>
           <a:prstGeom prst="rect">
@@ -34420,7 +35714,7 @@
         </p:nvSpPr>
         <p:spPr>
           <a:xfrm>
-            <a:off x="4581144" y="896112"/>
+            <a:off x="4192524" y="896112"/>
             <a:ext cx="868680" cy="384048"/>
           </a:xfrm>
           <a:prstGeom prst="roundRect">
@@ -34447,7 +35741,7 @@
         </p:nvSpPr>
         <p:spPr>
           <a:xfrm>
-            <a:off x="4581144" y="896112"/>
+            <a:off x="4192524" y="896112"/>
             <a:ext cx="868680" cy="384048"/>
           </a:xfrm>
           <a:prstGeom prst="rect">
@@ -34486,7 +35780,7 @@
         </p:nvSpPr>
         <p:spPr>
           <a:xfrm>
-            <a:off x="5541264" y="896112"/>
+            <a:off x="5152644" y="896112"/>
             <a:ext cx="1143000" cy="384048"/>
           </a:xfrm>
           <a:prstGeom prst="roundRect">
@@ -34513,7 +35807,7 @@
         </p:nvSpPr>
         <p:spPr>
           <a:xfrm>
-            <a:off x="5541264" y="896112"/>
+            <a:off x="5152644" y="896112"/>
             <a:ext cx="1143000" cy="384048"/>
           </a:xfrm>
           <a:prstGeom prst="rect">
@@ -34552,7 +35846,7 @@
         </p:nvSpPr>
         <p:spPr>
           <a:xfrm>
-            <a:off x="6775704" y="896112"/>
+            <a:off x="6387084" y="896112"/>
             <a:ext cx="1234440" cy="384048"/>
           </a:xfrm>
           <a:prstGeom prst="roundRect">
@@ -34579,7 +35873,7 @@
         </p:nvSpPr>
         <p:spPr>
           <a:xfrm>
-            <a:off x="6775704" y="896112"/>
+            <a:off x="6387084" y="896112"/>
             <a:ext cx="1234440" cy="384048"/>
           </a:xfrm>
           <a:prstGeom prst="rect">
@@ -34613,6 +35907,72 @@
       <p:sp>
         <p:nvSpPr>
           <p:cNvPr id="14" name="Shape 12"/>
+          <p:cNvSpPr/>
+          <p:nvPr/>
+        </p:nvSpPr>
+        <p:spPr>
+          <a:xfrm>
+            <a:off x="7712964" y="896112"/>
+            <a:ext cx="685800" cy="384048"/>
+          </a:xfrm>
+          <a:prstGeom prst="roundRect">
+            <a:avLst>
+              <a:gd name="adj" fmla="val 19048"/>
+            </a:avLst>
+          </a:prstGeom>
+          <a:solidFill>
+            <a:srgbClr val="262633"/>
+          </a:solidFill>
+          <a:ln w="12700">
+            <a:solidFill>
+              <a:srgbClr val="9A9AB0"/>
+            </a:solidFill>
+            <a:prstDash val="solid"/>
+          </a:ln>
+        </p:spPr>
+      </p:sp>
+      <p:sp>
+        <p:nvSpPr>
+          <p:cNvPr id="15" name="TimerResetBtn"/>
+          <p:cNvSpPr/>
+          <p:nvPr/>
+        </p:nvSpPr>
+        <p:spPr>
+          <a:xfrm>
+            <a:off x="7712964" y="896112"/>
+            <a:ext cx="685800" cy="384048"/>
+          </a:xfrm>
+          <a:prstGeom prst="rect">
+            <a:avLst/>
+          </a:prstGeom>
+          <a:noFill/>
+          <a:ln/>
+        </p:spPr>
+        <p:txBody>
+          <a:bodyPr wrap="square" lIns="0" tIns="0" rIns="0" bIns="0" rtlCol="0" anchor="ctr"/>
+          <a:lstStyle/>
+          <a:p>
+            <a:pPr algn="ctr" indent="0" marL="0">
+              <a:buNone/>
+            </a:pPr>
+            <a:r>
+              <a:rPr lang="en-US" sz="1100" b="1" dirty="0">
+                <a:solidFill>
+                  <a:srgbClr val="9A9AB0"/>
+                </a:solidFill>
+                <a:latin typeface="Calibri" pitchFamily="34" charset="0"/>
+                <a:ea typeface="Calibri" pitchFamily="34" charset="-122"/>
+                <a:cs typeface="Calibri" pitchFamily="34" charset="-120"/>
+              </a:rPr>
+              <a:t>RESET</a:t>
+            </a:r>
+            <a:endParaRPr lang="en-US" sz="1100" dirty="0"/>
+          </a:p>
+        </p:txBody>
+      </p:sp>
+      <p:sp>
+        <p:nvSpPr>
+          <p:cNvPr id="16" name="Shape 14"/>
           <p:cNvSpPr/>
           <p:nvPr/>
         </p:nvSpPr>
@@ -34639,7 +35999,7 @@
       </p:sp>
       <p:sp>
         <p:nvSpPr>
-          <p:cNvPr id="15" name="Text 13"/>
+          <p:cNvPr id="17" name="Text 15"/>
           <p:cNvSpPr/>
           <p:nvPr/>
         </p:nvSpPr>
@@ -34683,7 +36043,7 @@
       </p:sp>
       <p:sp>
         <p:nvSpPr>
-          <p:cNvPr id="16" name="Text 14"/>
+          <p:cNvPr id="18" name="Text 16"/>
           <p:cNvSpPr/>
           <p:nvPr/>
         </p:nvSpPr>
@@ -34722,7 +36082,7 @@
       </p:sp>
       <p:sp>
         <p:nvSpPr>
-          <p:cNvPr id="17" name="Text 15"/>
+          <p:cNvPr id="19" name="Text 17"/>
           <p:cNvSpPr/>
           <p:nvPr/>
         </p:nvSpPr>

</xml_diff>

<commit_message>
Avoid relying on ThisPresentation for auto-reset activation
Mac PowerPoint's VBA editor often doesn't expose "ThisPresentation" in
the Project pane, making it impossible to paste the Presentation_Open
handler there. Added ActivateAutoReset, a macro the host runs once per
session (same habit as SetupTimerButtons) instead of relying on that
special module. ThisPresentation_snippet.txt is now marked optional for
setups where it does work, and the in-deck setup slide reflects the
simpler path.
</commit_message>
<xml_diff>
--- a/Physics-League-Kinematics-Championship.pptx
+++ b/Physics-League-Kinematics-Championship.pptx
@@ -17879,7 +17879,7 @@
                 <a:ea typeface="Calibri" pitchFamily="34" charset="-122"/>
                 <a:cs typeface="Calibri" pitchFamily="34" charset="-120"/>
               </a:rPr>
-              <a:t>Double-click “ThisPresentation” in the project tree and paste in the short startup snippet (provided separately).</a:t>
+              <a:t>Click into PhysicsLeagueTimer.bas and press F5, then run “SetupTimerButtons” — once. A message box confirms how many buttons were wired.</a:t>
             </a:r>
             <a:endParaRPr lang="en-US" sz="1900" dirty="0"/>
           </a:p>
@@ -17919,47 +17919,7 @@
                 <a:ea typeface="Calibri" pitchFamily="34" charset="-122"/>
                 <a:cs typeface="Calibri" pitchFamily="34" charset="-120"/>
               </a:rPr>
-              <a:t>Click into PhysicsLeagueTimer.bas and press F5 to run “SetupTimerButtons” — once. A message box confirms how many buttons were wired.</a:t>
-            </a:r>
-            <a:endParaRPr lang="en-US" sz="1900" dirty="0"/>
-          </a:p>
-          <a:p>
-            <a:pPr algn="l" indent="0" marL="0">
-              <a:lnSpc>
-                <a:spcPct val="125000"/>
-              </a:lnSpc>
-              <a:buNone/>
-            </a:pPr>
-            <a:r>
-              <a:rPr lang="en-US" sz="1900" b="1" dirty="0">
-                <a:solidFill>
-                  <a:srgbClr val="FFD24A"/>
-                </a:solidFill>
-                <a:latin typeface="Calibri" pitchFamily="34" charset="0"/>
-                <a:ea typeface="Calibri" pitchFamily="34" charset="-122"/>
-                <a:cs typeface="Calibri" pitchFamily="34" charset="-120"/>
-              </a:rPr>
-              <a:t>6.  </a:t>
-            </a:r>
-            <a:pPr algn="l" indent="0" marL="0">
-              <a:lnSpc>
-                <a:spcPct val="125000"/>
-              </a:lnSpc>
-              <a:spcAft>
-                <a:spcPts val="1600"/>
-              </a:spcAft>
-              <a:buNone/>
-            </a:pPr>
-            <a:r>
-              <a:rPr lang="en-US" sz="1900" dirty="0">
-                <a:solidFill>
-                  <a:srgbClr val="F2F2F7"/>
-                </a:solidFill>
-                <a:latin typeface="Calibri" pitchFamily="34" charset="0"/>
-                <a:ea typeface="Calibri" pitchFamily="34" charset="-122"/>
-                <a:cs typeface="Calibri" pitchFamily="34" charset="-120"/>
-              </a:rPr>
-              <a:t>Save and close the VBA editor. When you reopen the file later, click “Enable Content” to allow macros.</a:t>
+              <a:t>Save and close the VBA editor. When you reopen the file (now or next time), click “Enable Content”, then run “ActivateAutoReset” once each session — this turns on the finished-timer auto-reset.</a:t>
             </a:r>
             <a:endParaRPr lang="en-US" sz="1900" dirty="0"/>
           </a:p>

</xml_diff>